<commit_message>
Rebuild 3-slide write-up: real screenshot, built-vs-production-path split, measured evals
Co-Authored-By: Claude Sonnet 5 <noreply@anthropic.com>
</commit_message>
<xml_diff>
--- a/docs/Writeup.pptx
+++ b/docs/Writeup.pptx
@@ -504,19 +504,25 @@
           <a:lstStyle/>
           <a:p>
             <a:r>
-              <a:t>PRODUCT. The user is a fraud investigator (and their supervisor) who starts the day with a queue of engine-referred claims, most of which turn out benign. The job to be done is to decide quickly and defensibly which referrals deserve human time, and on those, to get the evidence, the reasoning and the next step without hunting through dozens of signals.</a:t>
+              <a:t>PRODUCT. The user is a fraud investigator, and their supervisor, who starts the day with engine-referred claims that are mostly benign. The job to be done is to decide quickly and defensibly which referrals deserve human time, and for those, to get evidence, reasoning and a next step without hunting through dozens of signals.</a:t>
             </a:r>
           </a:p>
           <a:p/>
           <a:p>
             <a:r>
-              <a:t>The data shaped the design: three tiers (8 extreme, 9 ambiguous, 33 clean), three 'silent' cases that a flag-counting model would call clean, and one claim number reused across a clean and a critical case. So rules handle the obvious, and AI plus humans spend their time on the ambiguous middle and on cross-case links.</a:t>
+              <a:t>The data shaped the design. The 50 cases fall into three tiers: 8 extreme on every signal, 9 ambiguous, 33 clean. Three 'silent' cases (C1026, C1040, C1042) trip no flag but carry five elevated signals, and claim number LTC-2034786 sits on a clean case (C1001) and a critical one (C1031). So rules take the obvious cases; AI and humans spend their effort on the ambiguous middle and on cross-case links.</a:t>
             </a:r>
           </a:p>
           <a:p/>
           <a:p>
             <a:r>
-              <a:t>DEMO PATH: open the Morning briefing, then a critical case, then C1001 (the linked-claim story).</a:t>
+              <a:t>The screenshot is the real prototype. Note '9 AI-unavailable': the free models rate-limit, and the product shows that honestly instead of inventing an assessment.</a:t>
+            </a:r>
+          </a:p>
+          <a:p/>
+          <a:p>
+            <a:r>
+              <a:t>DEMO PATH: Morning briefing, then a critical case, then C1001 (the linked-claim story).</a:t>
             </a:r>
           </a:p>
         </p:txBody>
@@ -586,31 +592,31 @@
           <a:lstStyle/>
           <a:p>
             <a:r>
-              <a:t>ARCHITECTURE. Not a single LLM call. Deterministic rules score every case first (thresholds come from natural breaks in the data, not guesses). A router with no LLM then sends each case down one of three lanes: 29 clean cases share one cheap batched call, 8 critical cases get a verifier only, and 13 ambiguous cases get the full crew.</a:t>
+              <a:t>ARCHITECTURE. Not one LLM call. Deterministic rules score every case first; thresholds come from natural breaks in the data. A router with no LLM then picks a lane: 29 clean cases share one cheap batched call (5 per call), 8 critical cases get a verifier only, and 13 ambiguous or linked cases get the full crew.</a:t>
             </a:r>
           </a:p>
           <a:p/>
           <a:p>
             <a:r>
-              <a:t>On the DEEP lane, specialists run in parallel only where their domain fired; an adversarial challenger argues the benign case; a verifier synthesises; a three-persona panel convenes only if the case is contested. Every output then goes through deterministic guardrails.</a:t>
+              <a:t>On the DEEP lane, specialists (billing, collusion and linkage, geography and utilization) run in parallel only where their domain fired, each with at most one tool. An adversarial challenger argues the benign case, a verifier on the strong model tier synthesises, and a three-persona panel convenes only when the case is contested. All of it runs in a small harness I wrote: budgets, tool allowlists, typed output with repair, fast-to-strong escalation, model fallback, traced spans. No agent framework, no RAG, no vector store.</a:t>
             </a:r>
           </a:p>
           <a:p/>
           <a:p>
             <a:r>
-              <a:t>GROUNDING: the model can only move the score by 20 points, the level is derived, every citation is re-checked against the record, and failures are shown as 'LLM unavailable', never invented.</a:t>
+              <a:t>GROUNDING is deterministic code around the model: citations re-checked against the record, score moves capped at 20 with the level derived, no CLEAR on HIGH/CRITICAL or a confirmed-fraud lookalike, failures shown as LLM_UNAVAILABLE.</a:t>
             </a:r>
           </a:p>
           <a:p/>
           <a:p>
             <a:r>
-              <a:t>MEASURED: 10/10 invariants, 5/5 counterfactual and prompt-injection tests; versus the single-judge baseline, 100% band agreement and 27% fewer tokens. The strong-tier verifier makes reference dollars higher (0.44 vs 0.12), so I do not claim it is cheaper in dollars.</a:t>
+              <a:t>MEASURED on the 50 cases (docs/EVAL.md): 10/10 invariants, 5/5 counterfactual and injection tests, 277/277 stored indicators re-verify, 100% band agreement with the single-judge baseline at 27% fewer tokens. The strong-tier verifier raises reference dollars ($0.44 vs $0.12), so I do not claim it is cheaper in dollars.</a:t>
             </a:r>
           </a:p>
           <a:p/>
           <a:p>
             <a:r>
-              <a:t>DEMO PATH: Investigation trace on C1001 (reused specialist, challenger, panel, and the linked-case floor overruling a -10 vote).</a:t>
+              <a:t>SCALING: right side is explicitly not built.</a:t>
             </a:r>
           </a:p>
         </p:txBody>
@@ -680,25 +686,25 @@
           <a:lstStyle/>
           <a:p>
             <a:r>
-              <a:t>HUMAN IN THE LOOP. The AI never changes a case's status: every clear, escalation, override and outcome is a human action with a reason, in an audit log. Investigators can see the rule score next to the AI score, check every indicator against its field and value, accept or reject it (rejections are respected next time), and read the agent trace and the guardrail removals.</a:t>
+              <a:t>HUMAN IN THE LOOP. The AI never changes a case's status. Every clear, escalation, override and fraud outcome is a human action with a reason, in an audit log. Investigators see the rule score beside the AI score, check every indicator against its field and value, accept or reject it (rejections are respected next time), and read the agent trace and guardrail removals. Notes steer the next assessment, and deleting a note purges it from assessments, chat and related-case context. Supervisors approve escalations, override blocklist declines and activate hard rules; investigators can only propose them.</a:t>
             </a:r>
           </a:p>
           <a:p/>
           <a:p>
             <a:r>
-              <a:t>Notes are the investigator's steering wheel: a note changes the next assessment, and deleting a note removes it from the AI's knowledge, the chat context, related-case context and audit text.</a:t>
+              <a:t>TRADE-OFFS. No labels means no accuracy claim; backtests use synthetic labels and say so. False negatives are the costliest risk and only discovered misses can be measured. The free models rate-limit, so some cases show LLM unavailable: shown, not faked.</a:t>
             </a:r>
           </a:p>
           <a:p/>
           <a:p>
             <a:r>
-              <a:t>TRADE-OFFS. No labels means no accuracy claim; backtests use synthetic labels and say so. False negatives are the costliest risk and only discovered misses can be measured, so the next step is a safety net: miss-rate tracking, look-back that reopens cleared lookalikes, an independent adversarial reviewer and audited sampling. I prototyped an anomaly detector and deliberately deferred it because it was unstable at 50 cases.</a:t>
+              <a:t>NEXT (not built): false-negative safety net (miss-rate tracking, look-back that reopens cleared lookalikes, independent adversarial reviewer, audit sampling with a statistical bound). I prototyped an anomaly detector and deferred it: flagged sets changed with the seed at 50 cases.</a:t>
             </a:r>
           </a:p>
           <a:p/>
           <a:p>
             <a:r>
-              <a:t>DEMO PATH: add a note, watch the assessment go stale, ask the chatbot about it, delete it; then a Blocklist decline and supervisor override; then the Rules tab backtest.</a:t>
+              <a:t>DEMO PATH: add a note, watch it go stale, ask the chatbot, delete it; Blocklist decline and override; Rules tab backtest.</a:t>
             </a:r>
           </a:p>
         </p:txBody>
@@ -3741,7 +3747,7 @@
                 </a:solidFill>
                 <a:latin typeface="Arial"/>
               </a:rPr>
-              <a:t>A Junior AI Investigator that triages the queue before a human opens it</a:t>
+              <a:t>Investigators open the tool to a triaged queue, not a blank one</a:t>
             </a:r>
           </a:p>
         </p:txBody>
@@ -3783,7 +3789,7 @@
                 </a:solidFill>
                 <a:latin typeface="Arial"/>
               </a:rPr>
-              <a:t>Product: who it is for, the job to be done, and what I chose to build versus leave out</a:t>
+              <a:t>Product  ·  the user, the job to be done, and what I chose to build and to cut</a:t>
             </a:r>
           </a:p>
         </p:txBody>
@@ -3881,7 +3887,7 @@
         <p:spPr>
           <a:xfrm>
             <a:off x="457200" y="1325880"/>
-            <a:ext cx="5440680" cy="1783080"/>
+            <a:ext cx="4983480" cy="1371600"/>
           </a:xfrm>
           <a:prstGeom prst="roundRect">
             <a:avLst>
@@ -3929,19 +3935,27 @@
                 </a:solidFill>
                 <a:latin typeface="Arial"/>
               </a:rPr>
-              <a:t>Who it is for, and the job to be done</a:t>
-            </a:r>
-          </a:p>
-          <a:p>
-            <a:pPr algn="l" marL="137160" indent="-137160">
-              <a:lnSpc>
-                <a:spcPct val="100000"/>
-              </a:lnSpc>
-              <a:spcAft>
-                <a:spcPts val="400"/>
-              </a:spcAft>
-              <a:buChar char="•"/>
-            </a:pPr>
+              <a:t>The user and the job</a:t>
+            </a:r>
+          </a:p>
+          <a:p>
+            <a:pPr algn="l">
+              <a:lnSpc>
+                <a:spcPct val="100000"/>
+              </a:lnSpc>
+              <a:spcAft>
+                <a:spcPts val="500"/>
+              </a:spcAft>
+            </a:pPr>
+            <a:r>
+              <a:rPr sz="1100" b="1" i="0">
+                <a:solidFill>
+                  <a:srgbClr val="1A1F2B"/>
+                </a:solidFill>
+                <a:latin typeface="Arial"/>
+              </a:rPr>
+              <a:t>User: </a:t>
+            </a:r>
             <a:r>
               <a:rPr sz="1100" b="0" i="0">
                 <a:solidFill>
@@ -3949,19 +3963,27 @@
                 </a:solidFill>
                 <a:latin typeface="Arial"/>
               </a:rPr>
-              <a:t>User: a fraud investigator, and their supervisor, who starts each day with engine-referred claims. Most turn out benign.</a:t>
-            </a:r>
-          </a:p>
-          <a:p>
-            <a:pPr algn="l" marL="137160" indent="-137160">
-              <a:lnSpc>
-                <a:spcPct val="100000"/>
-              </a:lnSpc>
-              <a:spcAft>
-                <a:spcPts val="400"/>
-              </a:spcAft>
-              <a:buChar char="•"/>
-            </a:pPr>
+              <a:t>a fraud investigator, and their supervisor, facing a daily queue of engine referrals that mostly turn out benign.</a:t>
+            </a:r>
+          </a:p>
+          <a:p>
+            <a:pPr algn="l">
+              <a:lnSpc>
+                <a:spcPct val="100000"/>
+              </a:lnSpc>
+              <a:spcAft>
+                <a:spcPts val="0"/>
+              </a:spcAft>
+            </a:pPr>
+            <a:r>
+              <a:rPr sz="1100" b="1" i="0">
+                <a:solidFill>
+                  <a:srgbClr val="1A1F2B"/>
+                </a:solidFill>
+                <a:latin typeface="Arial"/>
+              </a:rPr>
+              <a:t>Job: </a:t>
+            </a:r>
             <a:r>
               <a:rPr sz="1100" b="0" i="0">
                 <a:solidFill>
@@ -3969,41 +3991,63 @@
                 </a:solidFill>
                 <a:latin typeface="Arial"/>
               </a:rPr>
-              <a:t>Job: decide quickly and defensibly which referrals deserve human time, and for those, get the evidence, reasoning and next step without hunting through dozens of signals.</a:t>
-            </a:r>
-          </a:p>
-          <a:p>
-            <a:pPr algn="l" marL="137160" indent="-137160">
-              <a:lnSpc>
-                <a:spcPct val="100000"/>
-              </a:lnSpc>
-              <a:spcAft>
-                <a:spcPts val="400"/>
-              </a:spcAft>
-              <a:buChar char="•"/>
-            </a:pPr>
-            <a:r>
-              <a:rPr sz="1100" b="0" i="0">
-                <a:solidFill>
-                  <a:srgbClr val="1A1F2B"/>
-                </a:solidFill>
-                <a:latin typeface="Arial"/>
-              </a:rPr>
-              <a:t>The human stays in control; the AI does the first pass.</a:t>
-            </a:r>
-          </a:p>
-        </p:txBody>
-      </p:sp>
-      <p:sp>
-        <p:nvSpPr>
-          <p:cNvPr id="7" name="Rounded Rectangle 6"/>
+              <a:t>decide fast, and defensibly, which referrals deserve human time; on those, get evidence, reasoning and a next step without hunting through signals.</a:t>
+            </a:r>
+          </a:p>
+        </p:txBody>
+      </p:sp>
+      <p:sp>
+        <p:nvSpPr>
+          <p:cNvPr id="7" name="TextBox 6"/>
+          <p:cNvSpPr txBox="1"/>
+          <p:nvPr/>
+        </p:nvSpPr>
+        <p:spPr>
+          <a:xfrm>
+            <a:off x="457200" y="2834640"/>
+            <a:ext cx="4983480" cy="228600"/>
+          </a:xfrm>
+          <a:prstGeom prst="rect">
+            <a:avLst/>
+          </a:prstGeom>
+          <a:noFill/>
+        </p:spPr>
+        <p:txBody>
+          <a:bodyPr wrap="square" anchor="t" lIns="0" tIns="0" rIns="0" bIns="0">
+            <a:spAutoFit/>
+          </a:bodyPr>
+          <a:lstStyle/>
+          <a:p>
+            <a:pPr algn="l">
+              <a:lnSpc>
+                <a:spcPct val="100000"/>
+              </a:lnSpc>
+              <a:spcAft>
+                <a:spcPts val="0"/>
+              </a:spcAft>
+            </a:pPr>
+            <a:r>
+              <a:rPr sz="950" b="1" i="0">
+                <a:solidFill>
+                  <a:srgbClr val="5B6478"/>
+                </a:solidFill>
+                <a:latin typeface="Arial"/>
+              </a:rPr>
+              <a:t>WHAT THE 50-CASE CSV TOLD ME</a:t>
+            </a:r>
+          </a:p>
+        </p:txBody>
+      </p:sp>
+      <p:sp>
+        <p:nvSpPr>
+          <p:cNvPr id="8" name="Rounded Rectangle 7"/>
           <p:cNvSpPr/>
           <p:nvPr/>
         </p:nvSpPr>
         <p:spPr>
           <a:xfrm>
-            <a:off x="457200" y="3227832"/>
-            <a:ext cx="5440680" cy="2011680"/>
+            <a:off x="457200" y="3090672"/>
+            <a:ext cx="1572768" cy="896112"/>
           </a:xfrm>
           <a:prstGeom prst="roundRect">
             <a:avLst>
@@ -4011,7 +4055,7 @@
             </a:avLst>
           </a:prstGeom>
           <a:solidFill>
-            <a:srgbClr val="EEF0FD"/>
+            <a:srgbClr val="FEE4E2"/>
           </a:solidFill>
           <a:ln>
             <a:noFill/>
@@ -4033,119 +4077,58 @@
           </a:fontRef>
         </p:style>
         <p:txBody>
-          <a:bodyPr rtlCol="0" anchor="t" wrap="square" lIns="128016" tIns="91440" rIns="128016" bIns="73152"/>
-          <a:lstStyle/>
-          <a:p>
-            <a:pPr algn="l">
-              <a:lnSpc>
-                <a:spcPct val="100000"/>
-              </a:lnSpc>
-              <a:spcAft>
-                <a:spcPts val="500"/>
-              </a:spcAft>
-            </a:pPr>
-            <a:r>
-              <a:rPr sz="1300" b="1" i="0">
-                <a:solidFill>
-                  <a:srgbClr val="3B4FD8"/>
-                </a:solidFill>
-                <a:latin typeface="Arial"/>
-              </a:rPr>
-              <a:t>What the data told me (it shaped the design)</a:t>
-            </a:r>
-          </a:p>
-          <a:p>
-            <a:pPr algn="l" marL="137160" indent="-137160">
-              <a:lnSpc>
-                <a:spcPct val="100000"/>
-              </a:lnSpc>
-              <a:spcAft>
-                <a:spcPts val="400"/>
-              </a:spcAft>
-              <a:buChar char="•"/>
-            </a:pPr>
-            <a:r>
-              <a:rPr sz="1100" b="0" i="0">
-                <a:solidFill>
-                  <a:srgbClr val="1A1F2B"/>
-                </a:solidFill>
-                <a:latin typeface="Arial"/>
-              </a:rPr>
-              <a:t>50 cases fall into three tiers: 8 extreme on every signal, 9 ambiguous, 33 clean.</a:t>
-            </a:r>
-          </a:p>
-          <a:p>
-            <a:pPr algn="l" marL="137160" indent="-137160">
-              <a:lnSpc>
-                <a:spcPct val="100000"/>
-              </a:lnSpc>
-              <a:spcAft>
-                <a:spcPts val="400"/>
-              </a:spcAft>
-              <a:buChar char="•"/>
-            </a:pPr>
-            <a:r>
-              <a:rPr sz="1100" b="0" i="0">
-                <a:solidFill>
-                  <a:srgbClr val="1A1F2B"/>
-                </a:solidFill>
-                <a:latin typeface="Arial"/>
-              </a:rPr>
-              <a:t>3 'silent' cases trip no flag but have five elevated signals. A flag-count model scores them clean.</a:t>
-            </a:r>
-          </a:p>
-          <a:p>
-            <a:pPr algn="l" marL="137160" indent="-137160">
-              <a:lnSpc>
-                <a:spcPct val="100000"/>
-              </a:lnSpc>
-              <a:spcAft>
-                <a:spcPts val="400"/>
-              </a:spcAft>
-              <a:buChar char="•"/>
-            </a:pPr>
-            <a:r>
-              <a:rPr sz="1100" b="0" i="0">
-                <a:solidFill>
-                  <a:srgbClr val="1A1F2B"/>
-                </a:solidFill>
-                <a:latin typeface="Arial"/>
-              </a:rPr>
-              <a:t>One claim number sits on both a clean and a critical case. No per-row rule can see that.</a:t>
-            </a:r>
-          </a:p>
-          <a:p>
-            <a:pPr algn="l" marL="137160" indent="-137160">
-              <a:lnSpc>
-                <a:spcPct val="100000"/>
-              </a:lnSpc>
-              <a:spcAft>
-                <a:spcPts val="400"/>
-              </a:spcAft>
-              <a:buChar char="•"/>
-            </a:pPr>
-            <a:r>
-              <a:rPr sz="1100" b="0" i="0">
-                <a:solidFill>
-                  <a:srgbClr val="1A1F2B"/>
-                </a:solidFill>
-                <a:latin typeface="Arial"/>
-              </a:rPr>
-              <a:t>So: rules for the obvious; AI and humans for the ambiguous middle and cross-case links.</a:t>
-            </a:r>
-          </a:p>
-        </p:txBody>
-      </p:sp>
-      <p:sp>
-        <p:nvSpPr>
-          <p:cNvPr id="8" name="Rounded Rectangle 7"/>
+          <a:bodyPr rtlCol="0" anchor="ctr" wrap="square" lIns="128016" tIns="91440" rIns="128016" bIns="73152"/>
+          <a:lstStyle/>
+          <a:p>
+            <a:pPr algn="ctr">
+              <a:lnSpc>
+                <a:spcPct val="100000"/>
+              </a:lnSpc>
+              <a:spcAft>
+                <a:spcPts val="0"/>
+              </a:spcAft>
+            </a:pPr>
+            <a:r>
+              <a:rPr sz="2200" b="1" i="0">
+                <a:solidFill>
+                  <a:srgbClr val="B42318"/>
+                </a:solidFill>
+                <a:latin typeface="Arial"/>
+              </a:rPr>
+              <a:t>8</a:t>
+            </a:r>
+          </a:p>
+          <a:p>
+            <a:pPr algn="ctr">
+              <a:lnSpc>
+                <a:spcPct val="100000"/>
+              </a:lnSpc>
+              <a:spcAft>
+                <a:spcPts val="0"/>
+              </a:spcAft>
+            </a:pPr>
+            <a:r>
+              <a:rPr sz="1000" b="0" i="0">
+                <a:solidFill>
+                  <a:srgbClr val="5B6478"/>
+                </a:solidFill>
+                <a:latin typeface="Arial"/>
+              </a:rPr>
+              <a:t>extreme on every signal</a:t>
+            </a:r>
+          </a:p>
+        </p:txBody>
+      </p:sp>
+      <p:sp>
+        <p:nvSpPr>
+          <p:cNvPr id="9" name="Rounded Rectangle 8"/>
           <p:cNvSpPr/>
           <p:nvPr/>
         </p:nvSpPr>
         <p:spPr>
           <a:xfrm>
-            <a:off x="457200" y="5358384"/>
-            <a:ext cx="2240280" cy="950976"/>
+            <a:off x="2162556" y="3090672"/>
+            <a:ext cx="1572768" cy="896112"/>
           </a:xfrm>
           <a:prstGeom prst="roundRect">
             <a:avLst>
@@ -4153,7 +4136,7 @@
             </a:avLst>
           </a:prstGeom>
           <a:solidFill>
-            <a:srgbClr val="EEF0FD"/>
+            <a:srgbClr val="FEF3C7"/>
           </a:solidFill>
           <a:ln>
             <a:noFill/>
@@ -4189,11 +4172,11 @@
             <a:r>
               <a:rPr sz="2200" b="1" i="0">
                 <a:solidFill>
-                  <a:srgbClr val="3B4FD8"/>
-                </a:solidFill>
-                <a:latin typeface="Arial"/>
-              </a:rPr>
-              <a:t>8 · 9 · 33</a:t>
+                  <a:srgbClr val="A16207"/>
+                </a:solidFill>
+                <a:latin typeface="Arial"/>
+              </a:rPr>
+              <a:t>9</a:t>
             </a:r>
           </a:p>
           <a:p>
@@ -4212,88 +4195,7 @@
                 </a:solidFill>
                 <a:latin typeface="Arial"/>
               </a:rPr>
-              <a:t>case tiers in the data</a:t>
-            </a:r>
-          </a:p>
-        </p:txBody>
-      </p:sp>
-      <p:sp>
-        <p:nvSpPr>
-          <p:cNvPr id="9" name="Rounded Rectangle 8"/>
-          <p:cNvSpPr/>
-          <p:nvPr/>
-        </p:nvSpPr>
-        <p:spPr>
-          <a:xfrm>
-            <a:off x="2816352" y="5358384"/>
-            <a:ext cx="1554480" cy="950976"/>
-          </a:xfrm>
-          <a:prstGeom prst="roundRect">
-            <a:avLst>
-              <a:gd name="adj" fmla="val 5000"/>
-            </a:avLst>
-          </a:prstGeom>
-          <a:solidFill>
-            <a:srgbClr val="EEF0FD"/>
-          </a:solidFill>
-          <a:ln>
-            <a:noFill/>
-          </a:ln>
-          <a:effectLst/>
-        </p:spPr>
-        <p:style>
-          <a:lnRef idx="1">
-            <a:schemeClr val="accent1"/>
-          </a:lnRef>
-          <a:fillRef idx="3">
-            <a:schemeClr val="accent1"/>
-          </a:fillRef>
-          <a:effectRef idx="2">
-            <a:schemeClr val="accent1"/>
-          </a:effectRef>
-          <a:fontRef idx="minor">
-            <a:schemeClr val="lt1"/>
-          </a:fontRef>
-        </p:style>
-        <p:txBody>
-          <a:bodyPr rtlCol="0" anchor="ctr" wrap="square" lIns="128016" tIns="91440" rIns="128016" bIns="73152"/>
-          <a:lstStyle/>
-          <a:p>
-            <a:pPr algn="ctr">
-              <a:lnSpc>
-                <a:spcPct val="100000"/>
-              </a:lnSpc>
-              <a:spcAft>
-                <a:spcPts val="0"/>
-              </a:spcAft>
-            </a:pPr>
-            <a:r>
-              <a:rPr sz="2200" b="1" i="0">
-                <a:solidFill>
-                  <a:srgbClr val="3B4FD8"/>
-                </a:solidFill>
-                <a:latin typeface="Arial"/>
-              </a:rPr>
-              <a:t>17</a:t>
-            </a:r>
-          </a:p>
-          <a:p>
-            <a:pPr algn="ctr">
-              <a:lnSpc>
-                <a:spcPct val="100000"/>
-              </a:lnSpc>
-              <a:spcAft>
-                <a:spcPts val="0"/>
-              </a:spcAft>
-            </a:pPr>
-            <a:r>
-              <a:rPr sz="1000" b="0" i="0">
-                <a:solidFill>
-                  <a:srgbClr val="5B6478"/>
-                </a:solidFill>
-                <a:latin typeface="Arial"/>
-              </a:rPr>
-              <a:t>rules, thresholds from the data</a:t>
+              <a:t>ambiguous middle</a:t>
             </a:r>
           </a:p>
         </p:txBody>
@@ -4306,8 +4208,8 @@
         </p:nvSpPr>
         <p:spPr>
           <a:xfrm>
-            <a:off x="4489704" y="5358384"/>
-            <a:ext cx="1408176" cy="950976"/>
+            <a:off x="3867912" y="3090672"/>
+            <a:ext cx="1572768" cy="896112"/>
           </a:xfrm>
           <a:prstGeom prst="roundRect">
             <a:avLst>
@@ -4355,7 +4257,7 @@
                 </a:solidFill>
                 <a:latin typeface="Arial"/>
               </a:rPr>
-              <a:t>88</a:t>
+              <a:t>33</a:t>
             </a:r>
           </a:p>
           <a:p>
@@ -4374,7 +4276,7 @@
                 </a:solidFill>
                 <a:latin typeface="Arial"/>
               </a:rPr>
-              <a:t>tests passing</a:t>
+              <a:t>clean</a:t>
             </a:r>
           </a:p>
         </p:txBody>
@@ -4387,250 +4289,8 @@
         </p:nvSpPr>
         <p:spPr>
           <a:xfrm>
-            <a:off x="6126480" y="1325880"/>
-            <a:ext cx="5605272" cy="3200400"/>
-          </a:xfrm>
-          <a:prstGeom prst="roundRect">
-            <a:avLst>
-              <a:gd name="adj" fmla="val 5000"/>
-            </a:avLst>
-          </a:prstGeom>
-          <a:solidFill>
-            <a:srgbClr val="EEF0FD"/>
-          </a:solidFill>
-          <a:ln>
-            <a:noFill/>
-          </a:ln>
-          <a:effectLst/>
-        </p:spPr>
-        <p:style>
-          <a:lnRef idx="1">
-            <a:schemeClr val="accent1"/>
-          </a:lnRef>
-          <a:fillRef idx="3">
-            <a:schemeClr val="accent1"/>
-          </a:fillRef>
-          <a:effectRef idx="2">
-            <a:schemeClr val="accent1"/>
-          </a:effectRef>
-          <a:fontRef idx="minor">
-            <a:schemeClr val="lt1"/>
-          </a:fontRef>
-        </p:style>
-        <p:txBody>
-          <a:bodyPr rtlCol="0" anchor="t" wrap="square" lIns="128016" tIns="91440" rIns="128016" bIns="73152"/>
-          <a:lstStyle/>
-          <a:p>
-            <a:pPr algn="l">
-              <a:lnSpc>
-                <a:spcPct val="100000"/>
-              </a:lnSpc>
-              <a:spcAft>
-                <a:spcPts val="500"/>
-              </a:spcAft>
-            </a:pPr>
-            <a:r>
-              <a:rPr sz="1300" b="1" i="0">
-                <a:solidFill>
-                  <a:srgbClr val="3B4FD8"/>
-                </a:solidFill>
-                <a:latin typeface="Arial"/>
-              </a:rPr>
-              <a:t>What I built</a:t>
-            </a:r>
-          </a:p>
-          <a:p>
-            <a:pPr algn="l" marL="137160" indent="-137160">
-              <a:lnSpc>
-                <a:spcPct val="100000"/>
-              </a:lnSpc>
-              <a:spcAft>
-                <a:spcPts val="600"/>
-              </a:spcAft>
-              <a:buChar char="•"/>
-            </a:pPr>
-            <a:r>
-              <a:rPr sz="1100" b="0" i="0">
-                <a:solidFill>
-                  <a:srgbClr val="1A1F2B"/>
-                </a:solidFill>
-                <a:latin typeface="Arial"/>
-              </a:rPr>
-              <a:t>Morning briefing: risk counts and exposure, top cases, rule clusters, abnormal firing</a:t>
-            </a:r>
-          </a:p>
-          <a:p>
-            <a:pPr algn="l" marL="137160" indent="-137160">
-              <a:lnSpc>
-                <a:spcPct val="100000"/>
-              </a:lnSpc>
-              <a:spcAft>
-                <a:spcPts val="600"/>
-              </a:spcAft>
-              <a:buChar char="•"/>
-            </a:pPr>
-            <a:r>
-              <a:rPr sz="1100" b="0" i="0">
-                <a:solidFill>
-                  <a:srgbClr val="1A1F2B"/>
-                </a:solidFill>
-                <a:latin typeface="Arial"/>
-              </a:rPr>
-              <a:t>Per-case AI assessment: summary, grounded indicators, risk level, recommended action, full trace</a:t>
-            </a:r>
-          </a:p>
-          <a:p>
-            <a:pPr algn="l" marL="137160" indent="-137160">
-              <a:lnSpc>
-                <a:spcPct val="100000"/>
-              </a:lnSpc>
-              <a:spcAft>
-                <a:spcPts val="600"/>
-              </a:spcAft>
-              <a:buChar char="•"/>
-            </a:pPr>
-            <a:r>
-              <a:rPr sz="1100" b="0" i="0">
-                <a:solidFill>
-                  <a:srgbClr val="1A1F2B"/>
-                </a:solidFill>
-                <a:latin typeface="Arial"/>
-              </a:rPr>
-              <a:t>Chatbot with tools; notes it reads (deletable everywhere) plus notes and outcomes from related cases</a:t>
-            </a:r>
-          </a:p>
-          <a:p>
-            <a:pPr algn="l" marL="137160" indent="-137160">
-              <a:lnSpc>
-                <a:spcPct val="100000"/>
-              </a:lnSpc>
-              <a:spcAft>
-                <a:spcPts val="600"/>
-              </a:spcAft>
-              <a:buChar char="•"/>
-            </a:pPr>
-            <a:r>
-              <a:rPr sz="1100" b="0" i="0">
-                <a:solidFill>
-                  <a:srgbClr val="1A1F2B"/>
-                </a:solidFill>
-                <a:latin typeface="Arial"/>
-              </a:rPr>
-              <a:t>Bulk clear by filter or by selection, behind guardrails</a:t>
-            </a:r>
-          </a:p>
-          <a:p>
-            <a:pPr algn="l" marL="137160" indent="-137160">
-              <a:lnSpc>
-                <a:spcPct val="100000"/>
-              </a:lnSpc>
-              <a:spcAft>
-                <a:spcPts val="600"/>
-              </a:spcAft>
-              <a:buChar char="•"/>
-            </a:pPr>
-            <a:r>
-              <a:rPr sz="1100" b="0" i="0">
-                <a:solidFill>
-                  <a:srgbClr val="1A1F2B"/>
-                </a:solidFill>
-                <a:latin typeface="Arial"/>
-              </a:rPr>
-              <a:t>Escalation to a supervisor with an AI-drafted handoff</a:t>
-            </a:r>
-          </a:p>
-          <a:p>
-            <a:pPr algn="l" marL="137160" indent="-137160">
-              <a:lnSpc>
-                <a:spcPct val="100000"/>
-              </a:lnSpc>
-              <a:spcAft>
-                <a:spcPts val="600"/>
-              </a:spcAft>
-              <a:buChar char="•"/>
-            </a:pPr>
-            <a:r>
-              <a:rPr sz="1100" b="0" i="0">
-                <a:solidFill>
-                  <a:srgbClr val="1A1F2B"/>
-                </a:solidFill>
-                <a:latin typeface="Arial"/>
-              </a:rPr>
-              <a:t>Rules tab: create or tune rules live and backtest precision and recall</a:t>
-            </a:r>
-          </a:p>
-          <a:p>
-            <a:pPr algn="l" marL="137160" indent="-137160">
-              <a:lnSpc>
-                <a:spcPct val="100000"/>
-              </a:lnSpc>
-              <a:spcAft>
-                <a:spcPts val="600"/>
-              </a:spcAft>
-              <a:buChar char="•"/>
-            </a:pPr>
-            <a:r>
-              <a:rPr sz="1100" b="0" i="0">
-                <a:solidFill>
-                  <a:srgbClr val="1A1F2B"/>
-                </a:solidFill>
-                <a:latin typeface="Arial"/>
-              </a:rPr>
-              <a:t>Blocklist: hard rules that auto-decline, with supervisor override</a:t>
-            </a:r>
-          </a:p>
-          <a:p>
-            <a:pPr algn="l" marL="137160" indent="-137160">
-              <a:lnSpc>
-                <a:spcPct val="100000"/>
-              </a:lnSpc>
-              <a:spcAft>
-                <a:spcPts val="600"/>
-              </a:spcAft>
-              <a:buChar char="•"/>
-            </a:pPr>
-            <a:r>
-              <a:rPr sz="1100" b="0" i="0">
-                <a:solidFill>
-                  <a:srgbClr val="1A1F2B"/>
-                </a:solidFill>
-                <a:latin typeface="Arial"/>
-              </a:rPr>
-              <a:t>'Mark as FRAUD' feedback: lookalikes get flagged (rule R17)</a:t>
-            </a:r>
-          </a:p>
-          <a:p>
-            <a:pPr algn="l" marL="137160" indent="-137160">
-              <a:lnSpc>
-                <a:spcPct val="100000"/>
-              </a:lnSpc>
-              <a:spcAft>
-                <a:spcPts val="600"/>
-              </a:spcAft>
-              <a:buChar char="•"/>
-            </a:pPr>
-            <a:r>
-              <a:rPr sz="1100" b="0" i="0">
-                <a:solidFill>
-                  <a:srgbClr val="1A1F2B"/>
-                </a:solidFill>
-                <a:latin typeface="Arial"/>
-              </a:rPr>
-              <a:t>Audit log of every AI action and human decision</a:t>
-            </a:r>
-          </a:p>
-        </p:txBody>
-      </p:sp>
-      <p:sp>
-        <p:nvSpPr>
-          <p:cNvPr id="12" name="Rounded Rectangle 11"/>
-          <p:cNvSpPr/>
-          <p:nvPr/>
-        </p:nvSpPr>
-        <p:spPr>
-          <a:xfrm>
-            <a:off x="6126480" y="4645152"/>
-            <a:ext cx="5605272" cy="1664208"/>
+            <a:off x="457200" y="4114800"/>
+            <a:ext cx="4983480" cy="1207008"/>
           </a:xfrm>
           <a:prstGeom prst="roundRect">
             <a:avLst>
@@ -4665,42 +4325,310 @@
           <a:bodyPr rtlCol="0" anchor="t" wrap="square" lIns="128016" tIns="91440" rIns="128016" bIns="73152"/>
           <a:lstStyle/>
           <a:p>
+            <a:pPr algn="l" marL="137160" indent="-137160">
+              <a:lnSpc>
+                <a:spcPct val="100000"/>
+              </a:lnSpc>
+              <a:spcAft>
+                <a:spcPts val="400"/>
+              </a:spcAft>
+              <a:buChar char="•"/>
+            </a:pPr>
+            <a:r>
+              <a:rPr sz="1050" b="0" i="0">
+                <a:solidFill>
+                  <a:srgbClr val="1A1F2B"/>
+                </a:solidFill>
+                <a:latin typeface="Arial"/>
+              </a:rPr>
+              <a:t>3 'silent' cases trip no flag, yet carry 5 elevated signals. A flag-count model calls them clean.</a:t>
+            </a:r>
+          </a:p>
+          <a:p>
+            <a:pPr algn="l" marL="137160" indent="-137160">
+              <a:lnSpc>
+                <a:spcPct val="100000"/>
+              </a:lnSpc>
+              <a:spcAft>
+                <a:spcPts val="0"/>
+              </a:spcAft>
+              <a:buChar char="•"/>
+            </a:pPr>
+            <a:r>
+              <a:rPr sz="1050" b="0" i="0">
+                <a:solidFill>
+                  <a:srgbClr val="1A1F2B"/>
+                </a:solidFill>
+                <a:latin typeface="Arial"/>
+              </a:rPr>
+              <a:t>Claim number LTC-2034786 sits on a clean case and a critical one. No single-row rule can see that.</a:t>
+            </a:r>
+          </a:p>
+        </p:txBody>
+      </p:sp>
+      <p:sp>
+        <p:nvSpPr>
+          <p:cNvPr id="12" name="Rounded Rectangle 11"/>
+          <p:cNvSpPr/>
+          <p:nvPr/>
+        </p:nvSpPr>
+        <p:spPr>
+          <a:xfrm>
+            <a:off x="457200" y="5440680"/>
+            <a:ext cx="4983480" cy="914400"/>
+          </a:xfrm>
+          <a:prstGeom prst="roundRect">
+            <a:avLst>
+              <a:gd name="adj" fmla="val 5000"/>
+            </a:avLst>
+          </a:prstGeom>
+          <a:solidFill>
+            <a:srgbClr val="1A1F2B"/>
+          </a:solidFill>
+          <a:ln>
+            <a:noFill/>
+          </a:ln>
+          <a:effectLst/>
+        </p:spPr>
+        <p:style>
+          <a:lnRef idx="1">
+            <a:schemeClr val="accent1"/>
+          </a:lnRef>
+          <a:fillRef idx="3">
+            <a:schemeClr val="accent1"/>
+          </a:fillRef>
+          <a:effectRef idx="2">
+            <a:schemeClr val="accent1"/>
+          </a:effectRef>
+          <a:fontRef idx="minor">
+            <a:schemeClr val="lt1"/>
+          </a:fontRef>
+        </p:style>
+        <p:txBody>
+          <a:bodyPr rtlCol="0" anchor="ctr" wrap="square" lIns="128016" tIns="91440" rIns="128016" bIns="73152"/>
+          <a:lstStyle/>
+          <a:p>
             <a:pPr algn="l">
               <a:lnSpc>
                 <a:spcPct val="100000"/>
               </a:lnSpc>
               <a:spcAft>
-                <a:spcPts val="500"/>
-              </a:spcAft>
-            </a:pPr>
-            <a:r>
-              <a:rPr sz="1300" b="1" i="0">
-                <a:solidFill>
-                  <a:srgbClr val="3B4FD8"/>
-                </a:solidFill>
-                <a:latin typeface="Arial"/>
-              </a:rPr>
-              <a:t>Left out on purpose</a:t>
-            </a:r>
-          </a:p>
+                <a:spcPts val="0"/>
+              </a:spcAft>
+            </a:pPr>
+            <a:r>
+              <a:rPr sz="1150" b="1" i="0">
+                <a:solidFill>
+                  <a:srgbClr val="FFFFFF"/>
+                </a:solidFill>
+                <a:latin typeface="Arial"/>
+              </a:rPr>
+              <a:t>Design consequence: </a:t>
+            </a:r>
+            <a:r>
+              <a:rPr sz="1150" b="0" i="0">
+                <a:solidFill>
+                  <a:srgbClr val="FFFFFF"/>
+                </a:solidFill>
+                <a:latin typeface="Arial"/>
+              </a:rPr>
+              <a:t>rules take the obvious; AI and humans spend their time on the ambiguous middle and the cross-case links.</a:t>
+            </a:r>
+          </a:p>
+        </p:txBody>
+      </p:sp>
+      <p:pic>
+        <p:nvPicPr>
+          <p:cNvPr id="13" name="Picture 12" descr="screenshot_briefing.png"/>
+          <p:cNvPicPr>
+            <a:picLocks noChangeAspect="1"/>
+          </p:cNvPicPr>
+          <p:nvPr/>
+        </p:nvPicPr>
+        <p:blipFill>
+          <a:blip r:embed="rId3"/>
+          <a:stretch>
+            <a:fillRect/>
+          </a:stretch>
+        </p:blipFill>
+        <p:spPr>
+          <a:xfrm>
+            <a:off x="5669280" y="1325880"/>
+            <a:ext cx="6062472" cy="3031236"/>
+          </a:xfrm>
+          <a:prstGeom prst="rect">
+            <a:avLst/>
+          </a:prstGeom>
+          <a:ln w="12700">
+            <a:solidFill>
+              <a:srgbClr val="D9DDE7"/>
+            </a:solidFill>
+          </a:ln>
+        </p:spPr>
+      </p:pic>
+      <p:sp>
+        <p:nvSpPr>
+          <p:cNvPr id="14" name="TextBox 13"/>
+          <p:cNvSpPr txBox="1"/>
+          <p:nvPr/>
+        </p:nvSpPr>
+        <p:spPr>
+          <a:xfrm>
+            <a:off x="5669280" y="4370832"/>
+            <a:ext cx="6062472" cy="292608"/>
+          </a:xfrm>
+          <a:prstGeom prst="rect">
+            <a:avLst/>
+          </a:prstGeom>
+          <a:noFill/>
+        </p:spPr>
+        <p:txBody>
+          <a:bodyPr wrap="square" anchor="t" lIns="0" tIns="0" rIns="0" bIns="0">
+            <a:spAutoFit/>
+          </a:bodyPr>
+          <a:lstStyle/>
+          <a:p>
+            <a:pPr algn="l">
+              <a:lnSpc>
+                <a:spcPct val="100000"/>
+              </a:lnSpc>
+              <a:spcAft>
+                <a:spcPts val="0"/>
+              </a:spcAft>
+            </a:pPr>
+            <a:r>
+              <a:rPr sz="900" b="0" i="0">
+                <a:solidFill>
+                  <a:srgbClr val="5B6478"/>
+                </a:solidFill>
+                <a:latin typeface="Arial"/>
+              </a:rPr>
+              <a:t>The running prototype: Morning briefing. Cases the free models could not assess show as “AI-unavailable”; nothing is invented.</a:t>
+            </a:r>
+          </a:p>
+        </p:txBody>
+      </p:sp>
+      <p:sp>
+        <p:nvSpPr>
+          <p:cNvPr id="15" name="Rounded Rectangle 14"/>
+          <p:cNvSpPr/>
+          <p:nvPr/>
+        </p:nvSpPr>
+        <p:spPr>
+          <a:xfrm>
+            <a:off x="5669280" y="4681728"/>
+            <a:ext cx="1371600" cy="219456"/>
+          </a:xfrm>
+          <a:prstGeom prst="roundRect">
+            <a:avLst>
+              <a:gd name="adj" fmla="val 40000"/>
+            </a:avLst>
+          </a:prstGeom>
+          <a:solidFill>
+            <a:srgbClr val="3B4FD8"/>
+          </a:solidFill>
+          <a:ln>
+            <a:noFill/>
+          </a:ln>
+          <a:effectLst/>
+        </p:spPr>
+        <p:style>
+          <a:lnRef idx="1">
+            <a:schemeClr val="accent1"/>
+          </a:lnRef>
+          <a:fillRef idx="3">
+            <a:schemeClr val="accent1"/>
+          </a:fillRef>
+          <a:effectRef idx="2">
+            <a:schemeClr val="accent1"/>
+          </a:effectRef>
+          <a:fontRef idx="minor">
+            <a:schemeClr val="lt1"/>
+          </a:fontRef>
+        </p:style>
+        <p:txBody>
+          <a:bodyPr rtlCol="0" anchor="ctr" wrap="square" lIns="36576" tIns="0" rIns="36576" bIns="0"/>
+          <a:lstStyle/>
+          <a:p>
+            <a:pPr algn="ctr">
+              <a:lnSpc>
+                <a:spcPct val="100000"/>
+              </a:lnSpc>
+              <a:spcAft>
+                <a:spcPts val="0"/>
+              </a:spcAft>
+            </a:pPr>
+            <a:r>
+              <a:rPr sz="850" b="1" i="0">
+                <a:solidFill>
+                  <a:srgbClr val="FFFFFF"/>
+                </a:solidFill>
+                <a:latin typeface="Arial"/>
+              </a:rPr>
+              <a:t>BUILT IN PROTOTYPE</a:t>
+            </a:r>
+          </a:p>
+        </p:txBody>
+      </p:sp>
+      <p:sp>
+        <p:nvSpPr>
+          <p:cNvPr id="16" name="Rounded Rectangle 15"/>
+          <p:cNvSpPr/>
+          <p:nvPr/>
+        </p:nvSpPr>
+        <p:spPr>
+          <a:xfrm>
+            <a:off x="5669280" y="4956048"/>
+            <a:ext cx="3401568" cy="1399032"/>
+          </a:xfrm>
+          <a:prstGeom prst="roundRect">
+            <a:avLst>
+              <a:gd name="adj" fmla="val 5000"/>
+            </a:avLst>
+          </a:prstGeom>
+          <a:solidFill>
+            <a:srgbClr val="EEF0FD"/>
+          </a:solidFill>
+          <a:ln>
+            <a:noFill/>
+          </a:ln>
+          <a:effectLst/>
+        </p:spPr>
+        <p:style>
+          <a:lnRef idx="1">
+            <a:schemeClr val="accent1"/>
+          </a:lnRef>
+          <a:fillRef idx="3">
+            <a:schemeClr val="accent1"/>
+          </a:fillRef>
+          <a:effectRef idx="2">
+            <a:schemeClr val="accent1"/>
+          </a:effectRef>
+          <a:fontRef idx="minor">
+            <a:schemeClr val="lt1"/>
+          </a:fontRef>
+        </p:style>
+        <p:txBody>
+          <a:bodyPr rtlCol="0" anchor="t" wrap="square" lIns="109728" tIns="64008"/>
+          <a:lstStyle/>
           <a:p>
             <a:pPr algn="l" marL="137160" indent="-137160">
               <a:lnSpc>
                 <a:spcPct val="100000"/>
               </a:lnSpc>
               <a:spcAft>
-                <a:spcPts val="400"/>
+                <a:spcPts val="200"/>
               </a:spcAft>
               <a:buChar char="•"/>
             </a:pPr>
             <a:r>
-              <a:rPr sz="1100" b="0" i="0">
+              <a:rPr sz="1000" b="0" i="0">
                 <a:solidFill>
                   <a:srgbClr val="1A1F2B"/>
                 </a:solidFill>
                 <a:latin typeface="Arial"/>
               </a:rPr>
-              <a:t>Auth, multi-tenancy, deployment: not the AI experience.</a:t>
+              <a:t>Morning briefing: risk counts, exposure, clusters, abnormal firing</a:t>
             </a:r>
           </a:p>
           <a:p>
@@ -4709,18 +4637,18 @@
                 <a:spcPct val="100000"/>
               </a:lnSpc>
               <a:spcAft>
-                <a:spcPts val="400"/>
+                <a:spcPts val="200"/>
               </a:spcAft>
               <a:buChar char="•"/>
             </a:pPr>
             <a:r>
-              <a:rPr sz="1100" b="0" i="0">
+              <a:rPr sz="1000" b="0" i="0">
                 <a:solidFill>
                   <a:srgbClr val="1A1F2B"/>
                 </a:solidFill>
                 <a:latin typeface="Arial"/>
               </a:rPr>
-              <a:t>Training an ML model: there are no labels, so an accuracy claim would be made up.</a:t>
+              <a:t>Per-case assessment, evidence trace, accept / reject</a:t>
             </a:r>
           </a:p>
           <a:p>
@@ -4729,18 +4657,18 @@
                 <a:spcPct val="100000"/>
               </a:lnSpc>
               <a:spcAft>
-                <a:spcPts val="400"/>
+                <a:spcPts val="200"/>
               </a:spcAft>
               <a:buChar char="•"/>
             </a:pPr>
             <a:r>
-              <a:rPr sz="1100" b="0" i="0">
+              <a:rPr sz="1000" b="0" i="0">
                 <a:solidFill>
                   <a:srgbClr val="1A1F2B"/>
                 </a:solidFill>
                 <a:latin typeface="Arial"/>
               </a:rPr>
-              <a:t>Provider or member graph, external enrichment: the CSV has no IDs (the code supports them if a dataset has them).</a:t>
+              <a:t>Chat with tools; notes the AI reads</a:t>
             </a:r>
           </a:p>
           <a:p>
@@ -4749,18 +4677,163 @@
                 <a:spcPct val="100000"/>
               </a:lnSpc>
               <a:spcAft>
+                <a:spcPts val="200"/>
+              </a:spcAft>
+              <a:buChar char="•"/>
+            </a:pPr>
+            <a:r>
+              <a:rPr sz="1000" b="0" i="0">
+                <a:solidFill>
+                  <a:srgbClr val="1A1F2B"/>
+                </a:solidFill>
+                <a:latin typeface="Arial"/>
+              </a:rPr>
+              <a:t>Bulk clear, supervisor escalation, audit log</a:t>
+            </a:r>
+          </a:p>
+          <a:p>
+            <a:pPr algn="l" marL="137160" indent="-137160">
+              <a:lnSpc>
+                <a:spcPct val="100000"/>
+              </a:lnSpc>
+              <a:spcAft>
                 <a:spcPts val="0"/>
               </a:spcAft>
               <a:buChar char="•"/>
             </a:pPr>
             <a:r>
-              <a:rPr sz="1100" b="0" i="0">
+              <a:rPr sz="1000" b="0" i="0">
                 <a:solidFill>
                   <a:srgbClr val="1A1F2B"/>
                 </a:solidFill>
                 <a:latin typeface="Arial"/>
               </a:rPr>
-              <a:t>Assumptions: synthetic, unlabelled data; one row per referral; peer % is vs the same care type.</a:t>
+              <a:t>Rules tab, Blocklist, fraud-outcome feedback</a:t>
+            </a:r>
+          </a:p>
+        </p:txBody>
+      </p:sp>
+      <p:sp>
+        <p:nvSpPr>
+          <p:cNvPr id="17" name="Rounded Rectangle 16"/>
+          <p:cNvSpPr/>
+          <p:nvPr/>
+        </p:nvSpPr>
+        <p:spPr>
+          <a:xfrm>
+            <a:off x="9189720" y="4956048"/>
+            <a:ext cx="2542032" cy="1399032"/>
+          </a:xfrm>
+          <a:prstGeom prst="roundRect">
+            <a:avLst>
+              <a:gd name="adj" fmla="val 5000"/>
+            </a:avLst>
+          </a:prstGeom>
+          <a:solidFill>
+            <a:srgbClr val="FFFFFF"/>
+          </a:solidFill>
+          <a:ln w="12700">
+            <a:solidFill>
+              <a:srgbClr val="5B6478"/>
+            </a:solidFill>
+            <a:prstDash val="dash"/>
+          </a:ln>
+          <a:effectLst/>
+        </p:spPr>
+        <p:style>
+          <a:lnRef idx="1">
+            <a:schemeClr val="accent1"/>
+          </a:lnRef>
+          <a:fillRef idx="3">
+            <a:schemeClr val="accent1"/>
+          </a:fillRef>
+          <a:effectRef idx="2">
+            <a:schemeClr val="accent1"/>
+          </a:effectRef>
+          <a:fontRef idx="minor">
+            <a:schemeClr val="lt1"/>
+          </a:fontRef>
+        </p:style>
+        <p:txBody>
+          <a:bodyPr rtlCol="0" anchor="t" wrap="square" lIns="109728" tIns="64008"/>
+          <a:lstStyle/>
+          <a:p>
+            <a:pPr algn="l">
+              <a:lnSpc>
+                <a:spcPct val="100000"/>
+              </a:lnSpc>
+              <a:spcAft>
+                <a:spcPts val="300"/>
+              </a:spcAft>
+            </a:pPr>
+            <a:r>
+              <a:rPr sz="1050" b="1" i="0">
+                <a:solidFill>
+                  <a:srgbClr val="5B6478"/>
+                </a:solidFill>
+                <a:latin typeface="Arial"/>
+              </a:rPr>
+              <a:t>Cut on purpose</a:t>
+            </a:r>
+          </a:p>
+          <a:p>
+            <a:pPr algn="l" marL="137160" indent="-137160">
+              <a:lnSpc>
+                <a:spcPct val="100000"/>
+              </a:lnSpc>
+              <a:spcAft>
+                <a:spcPts val="200"/>
+              </a:spcAft>
+              <a:buChar char="•"/>
+            </a:pPr>
+            <a:r>
+              <a:rPr sz="1000" b="0" i="0">
+                <a:solidFill>
+                  <a:srgbClr val="1A1F2B"/>
+                </a:solidFill>
+                <a:latin typeface="Arial"/>
+              </a:rPr>
+              <a:t>Auth, multi-tenancy, deploy</a:t>
+            </a:r>
+          </a:p>
+          <a:p>
+            <a:pPr algn="l" marL="137160" indent="-137160">
+              <a:lnSpc>
+                <a:spcPct val="100000"/>
+              </a:lnSpc>
+              <a:spcAft>
+                <a:spcPts val="200"/>
+              </a:spcAft>
+              <a:buChar char="•"/>
+            </a:pPr>
+            <a:r>
+              <a:rPr sz="1000" b="0" i="0">
+                <a:solidFill>
+                  <a:srgbClr val="1A1F2B"/>
+                </a:solidFill>
+                <a:latin typeface="Arial"/>
+              </a:rPr>
+              <a:t>ML training: no labels</a:t>
+            </a:r>
+          </a:p>
+          <a:p>
+            <a:pPr algn="l" marL="137160" indent="-137160">
+              <a:lnSpc>
+                <a:spcPct val="100000"/>
+              </a:lnSpc>
+              <a:spcAft>
+                <a:spcPts val="0"/>
+              </a:spcAft>
+              <a:buChar char="•"/>
+            </a:pPr>
+            <a:r>
+              <a:rPr sz="1000" b="0" i="0">
+                <a:solidFill>
+                  <a:srgbClr val="1A1F2B"/>
+                </a:solidFill>
+                <a:latin typeface="Arial"/>
+              </a:rPr>
+              <a:t>Provider / member graph: no IDs in the CSV</a:t>
             </a:r>
           </a:p>
         </p:txBody>
@@ -4820,7 +4893,7 @@
                 </a:solidFill>
                 <a:latin typeface="Arial"/>
               </a:rPr>
-              <a:t>Rules first; agents reason only as deep as each case needs</a:t>
+              <a:t>Rules set the depth; a tool-using agent crew reasons only where it pays</a:t>
             </a:r>
           </a:p>
         </p:txBody>
@@ -4862,7 +4935,7 @@
                 </a:solidFill>
                 <a:latin typeface="Arial"/>
               </a:rPr>
-              <a:t>Architecture: how the system reasons, stays grounded, and scales</a:t>
+              <a:t>Architecture  ·  how a case is reasoned about, kept grounded, and scaled</a:t>
             </a:r>
           </a:p>
         </p:txBody>
@@ -4953,14 +5026,65 @@
       </p:sp>
       <p:sp>
         <p:nvSpPr>
-          <p:cNvPr id="6" name="Rounded Rectangle 5"/>
+          <p:cNvPr id="6" name="TextBox 5"/>
+          <p:cNvSpPr txBox="1"/>
+          <p:nvPr/>
+        </p:nvSpPr>
+        <p:spPr>
+          <a:xfrm>
+            <a:off x="6949440" y="850392"/>
+            <a:ext cx="4782312" cy="274320"/>
+          </a:xfrm>
+          <a:prstGeom prst="rect">
+            <a:avLst/>
+          </a:prstGeom>
+          <a:noFill/>
+        </p:spPr>
+        <p:txBody>
+          <a:bodyPr wrap="square" anchor="t" lIns="0" tIns="0" rIns="0" bIns="0">
+            <a:spAutoFit/>
+          </a:bodyPr>
+          <a:lstStyle/>
+          <a:p>
+            <a:pPr algn="r">
+              <a:lnSpc>
+                <a:spcPct val="100000"/>
+              </a:lnSpc>
+              <a:spcAft>
+                <a:spcPts val="0"/>
+              </a:spcAft>
+            </a:pPr>
+            <a:r>
+              <a:rPr sz="1000" b="1" i="0">
+                <a:solidFill>
+                  <a:srgbClr val="3B4FD8"/>
+                </a:solidFill>
+                <a:latin typeface="Arial"/>
+              </a:rPr>
+              <a:t>Solid = built in the prototype    </a:t>
+            </a:r>
+            <a:r>
+              <a:rPr sz="1000" b="1" i="0">
+                <a:solidFill>
+                  <a:srgbClr val="5B6478"/>
+                </a:solidFill>
+                <a:latin typeface="Arial"/>
+              </a:rPr>
+              <a:t>Dashed = production path, not built</a:t>
+            </a:r>
+          </a:p>
+        </p:txBody>
+      </p:sp>
+      <p:sp>
+        <p:nvSpPr>
+          <p:cNvPr id="7" name="Rounded Rectangle 6"/>
           <p:cNvSpPr/>
           <p:nvPr/>
         </p:nvSpPr>
         <p:spPr>
           <a:xfrm>
             <a:off x="457200" y="1298448"/>
-            <a:ext cx="1965960" cy="713232"/>
+            <a:ext cx="2286000" cy="731520"/>
           </a:xfrm>
           <a:prstGeom prst="roundRect">
             <a:avLst>
@@ -5002,13 +5126,13 @@
               </a:spcAft>
             </a:pPr>
             <a:r>
-              <a:rPr sz="1050" b="1" i="0">
+              <a:rPr sz="1100" b="1" i="0">
                 <a:solidFill>
                   <a:srgbClr val="1A1F2B"/>
                 </a:solidFill>
                 <a:latin typeface="Arial"/>
               </a:rPr>
-              <a:t>CSV + derived features</a:t>
+              <a:t>50-case CSV</a:t>
             </a:r>
           </a:p>
           <a:p>
@@ -5027,20 +5151,20 @@
                 </a:solidFill>
                 <a:latin typeface="Arial"/>
               </a:rPr>
-              <a:t>travel miles, log-z, links</a:t>
-            </a:r>
-          </a:p>
-        </p:txBody>
-      </p:sp>
-      <p:sp>
-        <p:nvSpPr>
-          <p:cNvPr id="7" name="Right Arrow 6"/>
+              <a:t>features: log-z, travel, claim links</a:t>
+            </a:r>
+          </a:p>
+        </p:txBody>
+      </p:sp>
+      <p:sp>
+        <p:nvSpPr>
+          <p:cNvPr id="8" name="Right Arrow 7"/>
           <p:cNvSpPr/>
           <p:nvPr/>
         </p:nvSpPr>
         <p:spPr>
           <a:xfrm>
-            <a:off x="2468880" y="1536192"/>
+            <a:off x="2798064" y="1545336"/>
             <a:ext cx="256032" cy="237744"/>
           </a:xfrm>
           <a:prstGeom prst="rightArrow">
@@ -5077,14 +5201,14 @@
       </p:sp>
       <p:sp>
         <p:nvSpPr>
-          <p:cNvPr id="8" name="Rounded Rectangle 7"/>
+          <p:cNvPr id="9" name="Rounded Rectangle 8"/>
           <p:cNvSpPr/>
           <p:nvPr/>
         </p:nvSpPr>
         <p:spPr>
           <a:xfrm>
-            <a:off x="2788920" y="1298448"/>
-            <a:ext cx="2606040" cy="713232"/>
+            <a:off x="3108960" y="1298448"/>
+            <a:ext cx="2743200" cy="731520"/>
           </a:xfrm>
           <a:prstGeom prst="roundRect">
             <a:avLst>
@@ -5126,13 +5250,13 @@
               </a:spcAft>
             </a:pPr>
             <a:r>
-              <a:rPr sz="1050" b="1" i="0">
+              <a:rPr sz="1100" b="1" i="0">
                 <a:solidFill>
                   <a:srgbClr val="1A1F2B"/>
                 </a:solidFill>
                 <a:latin typeface="Arial"/>
               </a:rPr>
-              <a:t>17 rules (R01–R17)</a:t>
+              <a:t>17 rules, R01–R17</a:t>
             </a:r>
           </a:p>
           <a:p>
@@ -5151,20 +5275,20 @@
                 </a:solidFill>
                 <a:latin typeface="Arial"/>
               </a:rPr>
-              <a:t>thresholds from natural breaks in the data</a:t>
-            </a:r>
-          </a:p>
-        </p:txBody>
-      </p:sp>
-      <p:sp>
-        <p:nvSpPr>
-          <p:cNvPr id="9" name="Right Arrow 8"/>
+              <a:t>thresholds = natural breaks in the data</a:t>
+            </a:r>
+          </a:p>
+        </p:txBody>
+      </p:sp>
+      <p:sp>
+        <p:nvSpPr>
+          <p:cNvPr id="10" name="Right Arrow 9"/>
           <p:cNvSpPr/>
           <p:nvPr/>
         </p:nvSpPr>
         <p:spPr>
           <a:xfrm>
-            <a:off x="5440680" y="1536192"/>
+            <a:off x="5907024" y="1545336"/>
             <a:ext cx="256032" cy="237744"/>
           </a:xfrm>
           <a:prstGeom prst="rightArrow">
@@ -5201,14 +5325,14 @@
       </p:sp>
       <p:sp>
         <p:nvSpPr>
-          <p:cNvPr id="10" name="Rounded Rectangle 9"/>
+          <p:cNvPr id="11" name="Rounded Rectangle 10"/>
           <p:cNvSpPr/>
           <p:nvPr/>
         </p:nvSpPr>
         <p:spPr>
           <a:xfrm>
-            <a:off x="5760720" y="1298448"/>
-            <a:ext cx="2514600" cy="713232"/>
+            <a:off x="6217920" y="1298448"/>
+            <a:ext cx="2651760" cy="731520"/>
           </a:xfrm>
           <a:prstGeom prst="roundRect">
             <a:avLst>
@@ -5250,13 +5374,13 @@
               </a:spcAft>
             </a:pPr>
             <a:r>
-              <a:rPr sz="1050" b="1" i="0">
+              <a:rPr sz="1100" b="1" i="0">
                 <a:solidFill>
                   <a:srgbClr val="1A1F2B"/>
                 </a:solidFill>
                 <a:latin typeface="Arial"/>
               </a:rPr>
-              <a:t>Score 0–100</a:t>
+              <a:t>Score 0–100 + level</a:t>
             </a:r>
           </a:p>
           <a:p>
@@ -5275,20 +5399,20 @@
                 </a:solidFill>
                 <a:latin typeface="Arial"/>
               </a:rPr>
-              <a:t>strongest rule per domain, noisy-OR</a:t>
-            </a:r>
-          </a:p>
-        </p:txBody>
-      </p:sp>
-      <p:sp>
-        <p:nvSpPr>
-          <p:cNvPr id="11" name="Right Arrow 10"/>
+              <a:t>top rule per domain, noisy-OR</a:t>
+            </a:r>
+          </a:p>
+        </p:txBody>
+      </p:sp>
+      <p:sp>
+        <p:nvSpPr>
+          <p:cNvPr id="12" name="Right Arrow 11"/>
           <p:cNvSpPr/>
           <p:nvPr/>
         </p:nvSpPr>
         <p:spPr>
           <a:xfrm>
-            <a:off x="8321040" y="1536192"/>
+            <a:off x="8924544" y="1545336"/>
             <a:ext cx="256032" cy="237744"/>
           </a:xfrm>
           <a:prstGeom prst="rightArrow">
@@ -5325,14 +5449,14 @@
       </p:sp>
       <p:sp>
         <p:nvSpPr>
-          <p:cNvPr id="12" name="Rounded Rectangle 11"/>
+          <p:cNvPr id="13" name="Rounded Rectangle 12"/>
           <p:cNvSpPr/>
           <p:nvPr/>
         </p:nvSpPr>
         <p:spPr>
           <a:xfrm>
-            <a:off x="8641080" y="1298448"/>
-            <a:ext cx="3090672" cy="713232"/>
+            <a:off x="9235440" y="1298448"/>
+            <a:ext cx="2496312" cy="731520"/>
           </a:xfrm>
           <a:prstGeom prst="roundRect">
             <a:avLst>
@@ -5374,13 +5498,13 @@
               </a:spcAft>
             </a:pPr>
             <a:r>
-              <a:rPr sz="1050" b="1" i="0">
+              <a:rPr sz="1100" b="1" i="0">
                 <a:solidFill>
                   <a:srgbClr val="FFFFFF"/>
                 </a:solidFill>
                 <a:latin typeface="Arial"/>
               </a:rPr>
-              <a:t>Router: deterministic, no LLM</a:t>
+              <a:t>Router, no LLM</a:t>
             </a:r>
           </a:p>
           <a:p>
@@ -5399,21 +5523,21 @@
                 </a:solidFill>
                 <a:latin typeface="Arial"/>
               </a:rPr>
-              <a:t>picks depth from the fired rules</a:t>
-            </a:r>
-          </a:p>
-        </p:txBody>
-      </p:sp>
-      <p:sp>
-        <p:nvSpPr>
-          <p:cNvPr id="13" name="Rounded Rectangle 12"/>
+              <a:t>picks depth from the rules</a:t>
+            </a:r>
+          </a:p>
+        </p:txBody>
+      </p:sp>
+      <p:sp>
+        <p:nvSpPr>
+          <p:cNvPr id="14" name="Rounded Rectangle 13"/>
           <p:cNvSpPr/>
           <p:nvPr/>
         </p:nvSpPr>
         <p:spPr>
           <a:xfrm>
-            <a:off x="457200" y="2139696"/>
-            <a:ext cx="2377440" cy="1143000"/>
+            <a:off x="457200" y="2176272"/>
+            <a:ext cx="2514600" cy="1298448"/>
           </a:xfrm>
           <a:prstGeom prst="roundRect">
             <a:avLst>
@@ -5474,27 +5598,27 @@
               </a:spcAft>
             </a:pPr>
             <a:r>
-              <a:rPr sz="1100" b="0" i="0">
+              <a:rPr sz="1050" b="0" i="0">
                 <a:solidFill>
                   <a:srgbClr val="1A1F2B"/>
                 </a:solidFill>
                 <a:latin typeface="Arial"/>
               </a:rPr>
-              <a:t>No rule fired. One cheap call reviews 5 cases at once. No tools.</a:t>
-            </a:r>
-          </a:p>
-        </p:txBody>
-      </p:sp>
-      <p:sp>
-        <p:nvSpPr>
-          <p:cNvPr id="14" name="Rounded Rectangle 13"/>
+              <a:t>No rule fired, no link. One cheap call reviews 5 cases at once.</a:t>
+            </a:r>
+          </a:p>
+        </p:txBody>
+      </p:sp>
+      <p:sp>
+        <p:nvSpPr>
+          <p:cNvPr id="15" name="Rounded Rectangle 14"/>
           <p:cNvSpPr/>
           <p:nvPr/>
         </p:nvSpPr>
         <p:spPr>
           <a:xfrm>
-            <a:off x="2971800" y="2139696"/>
-            <a:ext cx="2377440" cy="1143000"/>
+            <a:off x="3081528" y="2176272"/>
+            <a:ext cx="2514600" cy="1298448"/>
           </a:xfrm>
           <a:prstGeom prst="roundRect">
             <a:avLst>
@@ -5555,27 +5679,27 @@
               </a:spcAft>
             </a:pPr>
             <a:r>
-              <a:rPr sz="1100" b="0" i="0">
+              <a:rPr sz="1050" b="0" i="0">
                 <a:solidFill>
                   <a:srgbClr val="1A1F2B"/>
                 </a:solidFill>
                 <a:latin typeface="Arial"/>
               </a:rPr>
-              <a:t>Rule level CRITICAL. Verifier only, since the facts are unambiguous.</a:t>
-            </a:r>
-          </a:p>
-        </p:txBody>
-      </p:sp>
-      <p:sp>
-        <p:nvSpPr>
-          <p:cNvPr id="15" name="Rounded Rectangle 14"/>
+              <a:t>Rule level CRITICAL. Verifier only: the facts are unambiguous, so no debate is bought.</a:t>
+            </a:r>
+          </a:p>
+        </p:txBody>
+      </p:sp>
+      <p:sp>
+        <p:nvSpPr>
+          <p:cNvPr id="16" name="Rounded Rectangle 15"/>
           <p:cNvSpPr/>
           <p:nvPr/>
         </p:nvSpPr>
         <p:spPr>
           <a:xfrm>
-            <a:off x="5486400" y="2139696"/>
-            <a:ext cx="6245352" cy="1143000"/>
+            <a:off x="5705856" y="2176272"/>
+            <a:ext cx="6025896" cy="1298448"/>
           </a:xfrm>
           <a:prstGeom prst="roundRect">
             <a:avLst>
@@ -5636,27 +5760,27 @@
               </a:spcAft>
             </a:pPr>
             <a:r>
-              <a:rPr sz="1100" b="0" i="0">
+              <a:rPr sz="1050" b="0" i="0">
                 <a:solidFill>
                   <a:srgbClr val="1A1F2B"/>
                 </a:solidFill>
                 <a:latin typeface="Arial"/>
               </a:rPr>
-              <a:t>Specialists run in parallel, only where their domain fired: billing, collusion and linkage, geography and utilization.  →  Adversarial challenger argues the benign case.  →  Verifier synthesises.  →  3-persona judge panel only if the case is contested.</a:t>
-            </a:r>
-          </a:p>
-        </p:txBody>
-      </p:sp>
-      <p:sp>
-        <p:nvSpPr>
-          <p:cNvPr id="16" name="Rounded Rectangle 15"/>
+              <a:t>Specialists in parallel, only where their domain fired (billing · collusion + linkage · geo/utilization, ≤1 tool each)  →  adversarial challenger  →  verifier (strong tier)  →  3-persona panel only if contested.</a:t>
+            </a:r>
+          </a:p>
+        </p:txBody>
+      </p:sp>
+      <p:sp>
+        <p:nvSpPr>
+          <p:cNvPr id="17" name="Rounded Rectangle 16"/>
           <p:cNvSpPr/>
           <p:nvPr/>
         </p:nvSpPr>
         <p:spPr>
           <a:xfrm>
-            <a:off x="457200" y="3401568"/>
-            <a:ext cx="11274552" cy="384048"/>
+            <a:off x="457200" y="3593592"/>
+            <a:ext cx="11274552" cy="512064"/>
           </a:xfrm>
           <a:prstGeom prst="roundRect">
             <a:avLst>
@@ -5704,7 +5828,7 @@
                 </a:solidFill>
                 <a:latin typeface="Arial"/>
               </a:rPr>
-              <a:t>Grounding gate </a:t>
+              <a:t>VERIFICATION BOUNDARY, deterministic code and not the model:  </a:t>
             </a:r>
             <a:r>
               <a:rPr sz="1000" b="0" i="0">
@@ -5713,21 +5837,306 @@
                 </a:solidFill>
                 <a:latin typeface="Arial"/>
               </a:rPr>
-              <a:t>on every output  →  assessment + investigation trace + cost.   Chat and agents share 9 read-only tools (peer stats, similar and linked cases, notes, search).</a:t>
-            </a:r>
-          </a:p>
-        </p:txBody>
-      </p:sp>
-      <p:sp>
-        <p:nvSpPr>
-          <p:cNvPr id="17" name="Rounded Rectangle 16"/>
+              <a:t>citations re-checked against the record  ·  score moves ≤ 20, level derived  ·  no CLEAR on HIGH/CRITICAL or fraud lookalike  ·  failure = “LLM unavailable”</a:t>
+            </a:r>
+          </a:p>
+        </p:txBody>
+      </p:sp>
+      <p:sp>
+        <p:nvSpPr>
+          <p:cNvPr id="18" name="TextBox 17"/>
+          <p:cNvSpPr txBox="1"/>
+          <p:nvPr/>
+        </p:nvSpPr>
+        <p:spPr>
+          <a:xfrm>
+            <a:off x="457200" y="4279392"/>
+            <a:ext cx="6675120" cy="201168"/>
+          </a:xfrm>
+          <a:prstGeom prst="rect">
+            <a:avLst/>
+          </a:prstGeom>
+          <a:noFill/>
+        </p:spPr>
+        <p:txBody>
+          <a:bodyPr wrap="square" anchor="t" lIns="0" tIns="0" rIns="0" bIns="0">
+            <a:spAutoFit/>
+          </a:bodyPr>
+          <a:lstStyle/>
+          <a:p>
+            <a:pPr algn="l">
+              <a:lnSpc>
+                <a:spcPct val="100000"/>
+              </a:lnSpc>
+              <a:spcAft>
+                <a:spcPts val="0"/>
+              </a:spcAft>
+            </a:pPr>
+            <a:r>
+              <a:rPr sz="950" b="1" i="0">
+                <a:solidFill>
+                  <a:srgbClr val="5B6478"/>
+                </a:solidFill>
+                <a:latin typeface="Arial"/>
+              </a:rPr>
+              <a:t>MEASURED ON THE 50 CASES  (docs/EVAL.md)</a:t>
+            </a:r>
+          </a:p>
+        </p:txBody>
+      </p:sp>
+      <p:sp>
+        <p:nvSpPr>
+          <p:cNvPr id="19" name="Rounded Rectangle 18"/>
           <p:cNvSpPr/>
           <p:nvPr/>
         </p:nvSpPr>
         <p:spPr>
           <a:xfrm>
-            <a:off x="457200" y="3931920"/>
-            <a:ext cx="3685032" cy="2423160"/>
+            <a:off x="457200" y="4535424"/>
+            <a:ext cx="1554480" cy="786384"/>
+          </a:xfrm>
+          <a:prstGeom prst="roundRect">
+            <a:avLst>
+              <a:gd name="adj" fmla="val 5000"/>
+            </a:avLst>
+          </a:prstGeom>
+          <a:solidFill>
+            <a:srgbClr val="D9F5E6"/>
+          </a:solidFill>
+          <a:ln>
+            <a:noFill/>
+          </a:ln>
+          <a:effectLst/>
+        </p:spPr>
+        <p:style>
+          <a:lnRef idx="1">
+            <a:schemeClr val="accent1"/>
+          </a:lnRef>
+          <a:fillRef idx="3">
+            <a:schemeClr val="accent1"/>
+          </a:fillRef>
+          <a:effectRef idx="2">
+            <a:schemeClr val="accent1"/>
+          </a:effectRef>
+          <a:fontRef idx="minor">
+            <a:schemeClr val="lt1"/>
+          </a:fontRef>
+        </p:style>
+        <p:txBody>
+          <a:bodyPr rtlCol="0" anchor="ctr" wrap="square" lIns="128016" tIns="91440" rIns="128016" bIns="73152"/>
+          <a:lstStyle/>
+          <a:p>
+            <a:pPr algn="ctr">
+              <a:lnSpc>
+                <a:spcPct val="100000"/>
+              </a:lnSpc>
+              <a:spcAft>
+                <a:spcPts val="0"/>
+              </a:spcAft>
+            </a:pPr>
+            <a:r>
+              <a:rPr sz="2200" b="1" i="0">
+                <a:solidFill>
+                  <a:srgbClr val="0E7A4B"/>
+                </a:solidFill>
+                <a:latin typeface="Arial"/>
+              </a:rPr>
+              <a:t>10 / 10</a:t>
+            </a:r>
+          </a:p>
+          <a:p>
+            <a:pPr algn="ctr">
+              <a:lnSpc>
+                <a:spcPct val="100000"/>
+              </a:lnSpc>
+              <a:spcAft>
+                <a:spcPts val="0"/>
+              </a:spcAft>
+            </a:pPr>
+            <a:r>
+              <a:rPr sz="1000" b="0" i="0">
+                <a:solidFill>
+                  <a:srgbClr val="5B6478"/>
+                </a:solidFill>
+                <a:latin typeface="Arial"/>
+              </a:rPr>
+              <a:t>behavioural invariants</a:t>
+            </a:r>
+          </a:p>
+        </p:txBody>
+      </p:sp>
+      <p:sp>
+        <p:nvSpPr>
+          <p:cNvPr id="20" name="Rounded Rectangle 19"/>
+          <p:cNvSpPr/>
+          <p:nvPr/>
+        </p:nvSpPr>
+        <p:spPr>
+          <a:xfrm>
+            <a:off x="2103120" y="4535424"/>
+            <a:ext cx="1554480" cy="786384"/>
+          </a:xfrm>
+          <a:prstGeom prst="roundRect">
+            <a:avLst>
+              <a:gd name="adj" fmla="val 5000"/>
+            </a:avLst>
+          </a:prstGeom>
+          <a:solidFill>
+            <a:srgbClr val="D9F5E6"/>
+          </a:solidFill>
+          <a:ln>
+            <a:noFill/>
+          </a:ln>
+          <a:effectLst/>
+        </p:spPr>
+        <p:style>
+          <a:lnRef idx="1">
+            <a:schemeClr val="accent1"/>
+          </a:lnRef>
+          <a:fillRef idx="3">
+            <a:schemeClr val="accent1"/>
+          </a:fillRef>
+          <a:effectRef idx="2">
+            <a:schemeClr val="accent1"/>
+          </a:effectRef>
+          <a:fontRef idx="minor">
+            <a:schemeClr val="lt1"/>
+          </a:fontRef>
+        </p:style>
+        <p:txBody>
+          <a:bodyPr rtlCol="0" anchor="ctr" wrap="square" lIns="128016" tIns="91440" rIns="128016" bIns="73152"/>
+          <a:lstStyle/>
+          <a:p>
+            <a:pPr algn="ctr">
+              <a:lnSpc>
+                <a:spcPct val="100000"/>
+              </a:lnSpc>
+              <a:spcAft>
+                <a:spcPts val="0"/>
+              </a:spcAft>
+            </a:pPr>
+            <a:r>
+              <a:rPr sz="2200" b="1" i="0">
+                <a:solidFill>
+                  <a:srgbClr val="0E7A4B"/>
+                </a:solidFill>
+                <a:latin typeface="Arial"/>
+              </a:rPr>
+              <a:t>5 / 5</a:t>
+            </a:r>
+          </a:p>
+          <a:p>
+            <a:pPr algn="ctr">
+              <a:lnSpc>
+                <a:spcPct val="100000"/>
+              </a:lnSpc>
+              <a:spcAft>
+                <a:spcPts val="0"/>
+              </a:spcAft>
+            </a:pPr>
+            <a:r>
+              <a:rPr sz="1000" b="0" i="0">
+                <a:solidFill>
+                  <a:srgbClr val="5B6478"/>
+                </a:solidFill>
+                <a:latin typeface="Arial"/>
+              </a:rPr>
+              <a:t>counterfactual tests</a:t>
+            </a:r>
+          </a:p>
+        </p:txBody>
+      </p:sp>
+      <p:sp>
+        <p:nvSpPr>
+          <p:cNvPr id="21" name="Rounded Rectangle 20"/>
+          <p:cNvSpPr/>
+          <p:nvPr/>
+        </p:nvSpPr>
+        <p:spPr>
+          <a:xfrm>
+            <a:off x="3749039" y="4535424"/>
+            <a:ext cx="1554480" cy="786384"/>
+          </a:xfrm>
+          <a:prstGeom prst="roundRect">
+            <a:avLst>
+              <a:gd name="adj" fmla="val 5000"/>
+            </a:avLst>
+          </a:prstGeom>
+          <a:solidFill>
+            <a:srgbClr val="D9F5E6"/>
+          </a:solidFill>
+          <a:ln>
+            <a:noFill/>
+          </a:ln>
+          <a:effectLst/>
+        </p:spPr>
+        <p:style>
+          <a:lnRef idx="1">
+            <a:schemeClr val="accent1"/>
+          </a:lnRef>
+          <a:fillRef idx="3">
+            <a:schemeClr val="accent1"/>
+          </a:fillRef>
+          <a:effectRef idx="2">
+            <a:schemeClr val="accent1"/>
+          </a:effectRef>
+          <a:fontRef idx="minor">
+            <a:schemeClr val="lt1"/>
+          </a:fontRef>
+        </p:style>
+        <p:txBody>
+          <a:bodyPr rtlCol="0" anchor="ctr" wrap="square" lIns="128016" tIns="91440" rIns="128016" bIns="73152"/>
+          <a:lstStyle/>
+          <a:p>
+            <a:pPr algn="ctr">
+              <a:lnSpc>
+                <a:spcPct val="100000"/>
+              </a:lnSpc>
+              <a:spcAft>
+                <a:spcPts val="0"/>
+              </a:spcAft>
+            </a:pPr>
+            <a:r>
+              <a:rPr sz="2200" b="1" i="0">
+                <a:solidFill>
+                  <a:srgbClr val="0E7A4B"/>
+                </a:solidFill>
+                <a:latin typeface="Arial"/>
+              </a:rPr>
+              <a:t>277 / 277</a:t>
+            </a:r>
+          </a:p>
+          <a:p>
+            <a:pPr algn="ctr">
+              <a:lnSpc>
+                <a:spcPct val="100000"/>
+              </a:lnSpc>
+              <a:spcAft>
+                <a:spcPts val="0"/>
+              </a:spcAft>
+            </a:pPr>
+            <a:r>
+              <a:rPr sz="1000" b="0" i="0">
+                <a:solidFill>
+                  <a:srgbClr val="5B6478"/>
+                </a:solidFill>
+                <a:latin typeface="Arial"/>
+              </a:rPr>
+              <a:t>indicators re-verified</a:t>
+            </a:r>
+          </a:p>
+        </p:txBody>
+      </p:sp>
+      <p:sp>
+        <p:nvSpPr>
+          <p:cNvPr id="22" name="Rounded Rectangle 21"/>
+          <p:cNvSpPr/>
+          <p:nvPr/>
+        </p:nvSpPr>
+        <p:spPr>
+          <a:xfrm>
+            <a:off x="5394960" y="4535424"/>
+            <a:ext cx="1554480" cy="786384"/>
           </a:xfrm>
           <a:prstGeom prst="roundRect">
             <a:avLst>
@@ -5757,119 +6166,58 @@
           </a:fontRef>
         </p:style>
         <p:txBody>
-          <a:bodyPr rtlCol="0" anchor="t" wrap="square" lIns="128016" tIns="91440" rIns="128016" bIns="73152"/>
-          <a:lstStyle/>
-          <a:p>
-            <a:pPr algn="l">
-              <a:lnSpc>
-                <a:spcPct val="100000"/>
-              </a:lnSpc>
-              <a:spcAft>
-                <a:spcPts val="500"/>
-              </a:spcAft>
-            </a:pPr>
-            <a:r>
-              <a:rPr sz="1300" b="1" i="0">
+          <a:bodyPr rtlCol="0" anchor="ctr" wrap="square" lIns="128016" tIns="91440" rIns="128016" bIns="73152"/>
+          <a:lstStyle/>
+          <a:p>
+            <a:pPr algn="ctr">
+              <a:lnSpc>
+                <a:spcPct val="100000"/>
+              </a:lnSpc>
+              <a:spcAft>
+                <a:spcPts val="0"/>
+              </a:spcAft>
+            </a:pPr>
+            <a:r>
+              <a:rPr sz="2200" b="1" i="0">
                 <a:solidFill>
                   <a:srgbClr val="3B4FD8"/>
                 </a:solidFill>
                 <a:latin typeface="Arial"/>
               </a:rPr>
-              <a:t>Grounded, not just prompted</a:t>
-            </a:r>
-          </a:p>
-          <a:p>
-            <a:pPr algn="l" marL="137160" indent="-137160">
-              <a:lnSpc>
-                <a:spcPct val="100000"/>
-              </a:lnSpc>
-              <a:spcAft>
-                <a:spcPts val="500"/>
-              </a:spcAft>
-              <a:buChar char="•"/>
-            </a:pPr>
-            <a:r>
-              <a:rPr sz="1100" b="0" i="0">
-                <a:solidFill>
-                  <a:srgbClr val="1A1F2B"/>
-                </a:solidFill>
-                <a:latin typeface="Arial"/>
-              </a:rPr>
-              <a:t>Rules are deterministic. The model moves the score by at most ±20; the level is derived from the score.</a:t>
-            </a:r>
-          </a:p>
-          <a:p>
-            <a:pPr algn="l" marL="137160" indent="-137160">
-              <a:lnSpc>
-                <a:spcPct val="100000"/>
-              </a:lnSpc>
-              <a:spcAft>
-                <a:spcPts val="500"/>
-              </a:spcAft>
-              <a:buChar char="•"/>
-            </a:pPr>
-            <a:r>
-              <a:rPr sz="1100" b="0" i="0">
-                <a:solidFill>
-                  <a:srgbClr val="1A1F2B"/>
-                </a:solidFill>
-                <a:latin typeface="Arial"/>
-              </a:rPr>
-              <a:t>Every cited field=value is re-checked against the record (286 of 286 stored indicators pass). Invented figures are flagged.</a:t>
-            </a:r>
-          </a:p>
-          <a:p>
-            <a:pPr algn="l" marL="137160" indent="-137160">
-              <a:lnSpc>
-                <a:spcPct val="100000"/>
-              </a:lnSpc>
-              <a:spcAft>
-                <a:spcPts val="500"/>
-              </a:spcAft>
-              <a:buChar char="•"/>
-            </a:pPr>
-            <a:r>
-              <a:rPr sz="1100" b="0" i="0">
-                <a:solidFill>
-                  <a:srgbClr val="1A1F2B"/>
-                </a:solidFill>
-                <a:latin typeface="Arial"/>
-              </a:rPr>
-              <a:t>It cannot recommend clearing a HIGH/CRITICAL case or a lookalike of a confirmed fraud, or downgrade a case linked to a CRITICAL one.</a:t>
-            </a:r>
-          </a:p>
-          <a:p>
-            <a:pPr algn="l" marL="137160" indent="-137160">
+              <a:t>−27%</a:t>
+            </a:r>
+          </a:p>
+          <a:p>
+            <a:pPr algn="ctr">
               <a:lnSpc>
                 <a:spcPct val="100000"/>
               </a:lnSpc>
               <a:spcAft>
                 <a:spcPts val="0"/>
               </a:spcAft>
-              <a:buChar char="•"/>
-            </a:pPr>
-            <a:r>
-              <a:rPr sz="1100" b="0" i="0">
-                <a:solidFill>
-                  <a:srgbClr val="1A1F2B"/>
-                </a:solidFill>
-                <a:latin typeface="Arial"/>
-              </a:rPr>
-              <a:t>Notes are untrusted input. Failures show as 'LLM unavailable', never invented text.</a:t>
-            </a:r>
-          </a:p>
-        </p:txBody>
-      </p:sp>
-      <p:sp>
-        <p:nvSpPr>
-          <p:cNvPr id="18" name="Rounded Rectangle 17"/>
+            </a:pPr>
+            <a:r>
+              <a:rPr sz="1000" b="0" i="0">
+                <a:solidFill>
+                  <a:srgbClr val="5B6478"/>
+                </a:solidFill>
+                <a:latin typeface="Arial"/>
+              </a:rPr>
+              <a:t>tokens vs single judge</a:t>
+            </a:r>
+          </a:p>
+        </p:txBody>
+      </p:sp>
+      <p:sp>
+        <p:nvSpPr>
+          <p:cNvPr id="23" name="Rounded Rectangle 22"/>
           <p:cNvSpPr/>
           <p:nvPr/>
         </p:nvSpPr>
         <p:spPr>
           <a:xfrm>
-            <a:off x="4251960" y="3931920"/>
-            <a:ext cx="3685032" cy="2423160"/>
+            <a:off x="457200" y="5431536"/>
+            <a:ext cx="6675120" cy="923544"/>
           </a:xfrm>
           <a:prstGeom prst="roundRect">
             <a:avLst>
@@ -5877,10 +6225,12 @@
             </a:avLst>
           </a:prstGeom>
           <a:solidFill>
-            <a:srgbClr val="EEF0FD"/>
+            <a:srgbClr val="F4F5F8"/>
           </a:solidFill>
-          <a:ln>
-            <a:noFill/>
+          <a:ln w="12700">
+            <a:solidFill>
+              <a:srgbClr val="D9DDE7"/>
+            </a:solidFill>
           </a:ln>
           <a:effectLst/>
         </p:spPr>
@@ -5899,45 +6249,26 @@
           </a:fontRef>
         </p:style>
         <p:txBody>
-          <a:bodyPr rtlCol="0" anchor="t" wrap="square" lIns="128016" tIns="91440" rIns="128016" bIns="73152"/>
-          <a:lstStyle/>
-          <a:p>
-            <a:pPr algn="l">
-              <a:lnSpc>
-                <a:spcPct val="100000"/>
-              </a:lnSpc>
-              <a:spcAft>
-                <a:spcPts val="500"/>
-              </a:spcAft>
-            </a:pPr>
-            <a:r>
-              <a:rPr sz="1300" b="1" i="0">
-                <a:solidFill>
-                  <a:srgbClr val="3B4FD8"/>
-                </a:solidFill>
-                <a:latin typeface="Arial"/>
-              </a:rPr>
-              <a:t>Harness and measurements</a:t>
-            </a:r>
-          </a:p>
+          <a:bodyPr rtlCol="0" anchor="t" wrap="square" lIns="109728" tIns="64008"/>
+          <a:lstStyle/>
           <a:p>
             <a:pPr algn="l" marL="137160" indent="-137160">
               <a:lnSpc>
                 <a:spcPct val="100000"/>
               </a:lnSpc>
               <a:spcAft>
-                <a:spcPts val="500"/>
+                <a:spcPts val="300"/>
               </a:spcAft>
               <a:buChar char="•"/>
             </a:pPr>
             <a:r>
-              <a:rPr sz="1100" b="0" i="0">
+              <a:rPr sz="1000" b="0" i="0">
                 <a:solidFill>
                   <a:srgbClr val="1A1F2B"/>
                 </a:solidFill>
                 <a:latin typeface="Arial"/>
               </a:rPr>
-              <a:t>Every agent has budgets, a tool allowlist, typed output with repair, fast→strong escalation, model fallback and traced calls.</a:t>
+              <a:t>Same 100% band agreement as the single-judge baseline; a new note re-runs 2 calls, not 5 (specialists reused by evidence hash).</a:t>
             </a:r>
           </a:p>
           <a:p>
@@ -5946,52 +6277,97 @@
                 <a:spcPct val="100000"/>
               </a:lnSpc>
               <a:spcAft>
-                <a:spcPts val="500"/>
+                <a:spcPts val="0"/>
               </a:spcAft>
               <a:buChar char="•"/>
             </a:pPr>
             <a:r>
-              <a:rPr sz="1100" b="0" i="0">
+              <a:rPr sz="1000" b="0" i="0">
                 <a:solidFill>
                   <a:srgbClr val="1A1F2B"/>
                 </a:solidFill>
                 <a:latin typeface="Arial"/>
               </a:rPr>
-              <a:t>10/10 behavioural invariants; 5/5 counterfactual and prompt-injection tests.</a:t>
-            </a:r>
-          </a:p>
-          <a:p>
-            <a:pPr algn="l" marL="137160" indent="-137160">
-              <a:lnSpc>
-                <a:spcPct val="100000"/>
-              </a:lnSpc>
-              <a:spcAft>
-                <a:spcPts val="0"/>
-              </a:spcAft>
-              <a:buChar char="•"/>
-            </a:pPr>
-            <a:r>
-              <a:rPr sz="1100" b="0" i="0">
-                <a:solidFill>
-                  <a:srgbClr val="1A1F2B"/>
-                </a:solidFill>
-                <a:latin typeface="Arial"/>
-              </a:rPr>
-              <a:t>Versus a single-judge baseline: 100% band agreement, 27% fewer tokens (238k vs 328k). A new note re-runs 2 calls, not 5.</a:t>
-            </a:r>
-          </a:p>
-        </p:txBody>
-      </p:sp>
-      <p:sp>
-        <p:nvSpPr>
-          <p:cNvPr id="19" name="Rounded Rectangle 18"/>
+              <a:t>Honest cost: $0.44 vs $0.12 reference, because the verifier uses the strong tier. Weak spot found: the challenger rates every case “medium”.</a:t>
+            </a:r>
+          </a:p>
+        </p:txBody>
+      </p:sp>
+      <p:sp>
+        <p:nvSpPr>
+          <p:cNvPr id="24" name="Rounded Rectangle 23"/>
           <p:cNvSpPr/>
           <p:nvPr/>
         </p:nvSpPr>
         <p:spPr>
           <a:xfrm>
-            <a:off x="8046720" y="3931920"/>
-            <a:ext cx="3685032" cy="2423160"/>
+            <a:off x="7315200" y="4279392"/>
+            <a:ext cx="2011680" cy="219456"/>
+          </a:xfrm>
+          <a:prstGeom prst="roundRect">
+            <a:avLst>
+              <a:gd name="adj" fmla="val 40000"/>
+            </a:avLst>
+          </a:prstGeom>
+          <a:solidFill>
+            <a:srgbClr val="FFFFFF"/>
+          </a:solidFill>
+          <a:ln w="12700">
+            <a:solidFill>
+              <a:srgbClr val="5B6478"/>
+            </a:solidFill>
+            <a:prstDash val="dash"/>
+          </a:ln>
+          <a:effectLst/>
+        </p:spPr>
+        <p:style>
+          <a:lnRef idx="1">
+            <a:schemeClr val="accent1"/>
+          </a:lnRef>
+          <a:fillRef idx="3">
+            <a:schemeClr val="accent1"/>
+          </a:fillRef>
+          <a:effectRef idx="2">
+            <a:schemeClr val="accent1"/>
+          </a:effectRef>
+          <a:fontRef idx="minor">
+            <a:schemeClr val="lt1"/>
+          </a:fontRef>
+        </p:style>
+        <p:txBody>
+          <a:bodyPr rtlCol="0" anchor="ctr" wrap="square" lIns="36576" tIns="0" rIns="36576" bIns="0"/>
+          <a:lstStyle/>
+          <a:p>
+            <a:pPr algn="ctr">
+              <a:lnSpc>
+                <a:spcPct val="100000"/>
+              </a:lnSpc>
+              <a:spcAft>
+                <a:spcPts val="0"/>
+              </a:spcAft>
+            </a:pPr>
+            <a:r>
+              <a:rPr sz="850" b="1" i="0">
+                <a:solidFill>
+                  <a:srgbClr val="5B6478"/>
+                </a:solidFill>
+                <a:latin typeface="Arial"/>
+              </a:rPr>
+              <a:t>PRODUCTION PATH: NOT BUILT</a:t>
+            </a:r>
+          </a:p>
+        </p:txBody>
+      </p:sp>
+      <p:sp>
+        <p:nvSpPr>
+          <p:cNvPr id="25" name="Rounded Rectangle 24"/>
+          <p:cNvSpPr/>
+          <p:nvPr/>
+        </p:nvSpPr>
+        <p:spPr>
+          <a:xfrm>
+            <a:off x="7315200" y="4553712"/>
+            <a:ext cx="4416552" cy="1801368"/>
           </a:xfrm>
           <a:prstGeom prst="roundRect">
             <a:avLst>
@@ -5999,10 +6375,13 @@
             </a:avLst>
           </a:prstGeom>
           <a:solidFill>
-            <a:srgbClr val="EEF0FD"/>
+            <a:srgbClr val="FFFFFF"/>
           </a:solidFill>
-          <a:ln>
-            <a:noFill/>
+          <a:ln w="12700">
+            <a:solidFill>
+              <a:srgbClr val="5B6478"/>
+            </a:solidFill>
+            <a:prstDash val="dash"/>
           </a:ln>
           <a:effectLst/>
         </p:spPr>
@@ -6021,7 +6400,7 @@
           </a:fontRef>
         </p:style>
         <p:txBody>
-          <a:bodyPr rtlCol="0" anchor="t" wrap="square" lIns="128016" tIns="91440" rIns="128016" bIns="73152"/>
+          <a:bodyPr rtlCol="0" anchor="t" wrap="square" lIns="128016" tIns="82296" rIns="109728" bIns="54864"/>
           <a:lstStyle/>
           <a:p>
             <a:pPr algn="l">
@@ -6029,97 +6408,54 @@
                 <a:spcPct val="100000"/>
               </a:lnSpc>
               <a:spcAft>
-                <a:spcPts val="500"/>
-              </a:spcAft>
-            </a:pPr>
-            <a:r>
-              <a:rPr sz="1300" b="1" i="0">
-                <a:solidFill>
-                  <a:srgbClr val="3B4FD8"/>
-                </a:solidFill>
-                <a:latin typeface="Arial"/>
-              </a:rPr>
-              <a:t>Beyond 50 cases</a:t>
-            </a:r>
-          </a:p>
-          <a:p>
-            <a:pPr algn="l" marL="137160" indent="-137160">
-              <a:lnSpc>
-                <a:spcPct val="100000"/>
-              </a:lnSpc>
-              <a:spcAft>
-                <a:spcPts val="500"/>
-              </a:spcAft>
-              <a:buChar char="•"/>
-            </a:pPr>
-            <a:r>
-              <a:rPr sz="1100" b="0" i="0">
+                <a:spcPts val="400"/>
+              </a:spcAft>
+            </a:pPr>
+            <a:r>
+              <a:rPr sz="1000" b="1" i="0">
                 <a:solidFill>
                   <a:srgbClr val="1A1F2B"/>
                 </a:solidFill>
                 <a:latin typeface="Arial"/>
               </a:rPr>
-              <a:t>Router cost is O(1) per case, so effort lands on the hard tail; real queues have a larger FAST share.</a:t>
-            </a:r>
-          </a:p>
-          <a:p>
-            <a:pPr algn="l" marL="137160" indent="-137160">
-              <a:lnSpc>
-                <a:spcPct val="100000"/>
-              </a:lnSpc>
-              <a:spcAft>
-                <a:spcPts val="500"/>
-              </a:spcAft>
-              <a:buChar char="•"/>
-            </a:pPr>
-            <a:r>
-              <a:rPr sz="1100" b="0" i="0">
+              <a:t>Prototype limits: </a:t>
+            </a:r>
+            <a:r>
+              <a:rPr sz="1000" b="0" i="0">
                 <a:solidFill>
                   <a:srgbClr val="1A1F2B"/>
                 </a:solidFill>
                 <a:latin typeface="Arial"/>
               </a:rPr>
-              <a:t>Batching, parallel subagents, reuse by evidence hash, model tiers and budgets keep cost bounded.</a:t>
-            </a:r>
-          </a:p>
-          <a:p>
-            <a:pPr algn="l" marL="137160" indent="-137160">
-              <a:lnSpc>
-                <a:spcPct val="100000"/>
-              </a:lnSpc>
-              <a:spcAft>
-                <a:spcPts val="500"/>
-              </a:spcAft>
-              <a:buChar char="•"/>
-            </a:pPr>
-            <a:r>
-              <a:rPr sz="1100" b="0" i="0">
+              <a:t>SQLite, in-process workers, O(n) similarity, ~4 sequential hops (≈65 s on free models): right for a morning batch, not per click.</a:t>
+            </a:r>
+          </a:p>
+          <a:p>
+            <a:pPr algn="l">
+              <a:lnSpc>
+                <a:spcPct val="100000"/>
+              </a:lnSpc>
+              <a:spcAft>
+                <a:spcPts val="0"/>
+              </a:spcAft>
+            </a:pPr>
+            <a:r>
+              <a:rPr sz="1000" b="1" i="0">
                 <a:solidFill>
                   <a:srgbClr val="1A1F2B"/>
                 </a:solidFill>
                 <a:latin typeface="Arial"/>
               </a:rPr>
-              <a:t>Prototype limits: SQLite, in-process workers, O(n) similarity. Next: Postgres, queue workers, a vector index.</a:t>
-            </a:r>
-          </a:p>
-          <a:p>
-            <a:pPr algn="l" marL="137160" indent="-137160">
-              <a:lnSpc>
-                <a:spcPct val="100000"/>
-              </a:lnSpc>
-              <a:spcAft>
-                <a:spcPts val="0"/>
-              </a:spcAft>
-              <a:buChar char="•"/>
-            </a:pPr>
-            <a:r>
-              <a:rPr sz="1100" b="0" i="0">
+              <a:t>Beyond 50 cases: </a:t>
+            </a:r>
+            <a:r>
+              <a:rPr sz="1000" b="0" i="0">
                 <a:solidFill>
                   <a:srgbClr val="1A1F2B"/>
                 </a:solidFill>
                 <a:latin typeface="Arial"/>
               </a:rPr>
-              <a:t>About 4 sequential LLM hops (≈65 s on free models): fine for a morning batch, not per click.</a:t>
+              <a:t>Postgres + queue workers; vector index for similarity; per-tenant budgets; streaming UI. Router stays O(1) per case, so spend lands on the hard tail (a real queue has a bigger FAST share).</a:t>
             </a:r>
           </a:p>
         </p:txBody>
@@ -6179,7 +6515,7 @@
                 </a:solidFill>
                 <a:latin typeface="Arial"/>
               </a:rPr>
-              <a:t>The AI advises, humans decide, and the risks are named</a:t>
+              <a:t>The AI advises, humans decide, and the known risks are named</a:t>
             </a:r>
           </a:p>
         </p:txBody>
@@ -6221,7 +6557,7 @@
                 </a:solidFill>
                 <a:latin typeface="Arial"/>
               </a:rPr>
-              <a:t>Human in the loop, trade-offs, and what I would do next</a:t>
+              <a:t>Human in the loop  ·  trade-offs  ·  what I would do with more time</a:t>
             </a:r>
           </a:p>
         </p:txBody>
@@ -6319,7 +6655,69 @@
         <p:spPr>
           <a:xfrm>
             <a:off x="457200" y="1298448"/>
-            <a:ext cx="3685032" cy="5056632"/>
+            <a:ext cx="1371600" cy="219456"/>
+          </a:xfrm>
+          <a:prstGeom prst="roundRect">
+            <a:avLst>
+              <a:gd name="adj" fmla="val 40000"/>
+            </a:avLst>
+          </a:prstGeom>
+          <a:solidFill>
+            <a:srgbClr val="3B4FD8"/>
+          </a:solidFill>
+          <a:ln>
+            <a:noFill/>
+          </a:ln>
+          <a:effectLst/>
+        </p:spPr>
+        <p:style>
+          <a:lnRef idx="1">
+            <a:schemeClr val="accent1"/>
+          </a:lnRef>
+          <a:fillRef idx="3">
+            <a:schemeClr val="accent1"/>
+          </a:fillRef>
+          <a:effectRef idx="2">
+            <a:schemeClr val="accent1"/>
+          </a:effectRef>
+          <a:fontRef idx="minor">
+            <a:schemeClr val="lt1"/>
+          </a:fontRef>
+        </p:style>
+        <p:txBody>
+          <a:bodyPr rtlCol="0" anchor="ctr" wrap="square" lIns="36576" tIns="0" rIns="36576" bIns="0"/>
+          <a:lstStyle/>
+          <a:p>
+            <a:pPr algn="ctr">
+              <a:lnSpc>
+                <a:spcPct val="100000"/>
+              </a:lnSpc>
+              <a:spcAft>
+                <a:spcPts val="0"/>
+              </a:spcAft>
+            </a:pPr>
+            <a:r>
+              <a:rPr sz="850" b="1" i="0">
+                <a:solidFill>
+                  <a:srgbClr val="FFFFFF"/>
+                </a:solidFill>
+                <a:latin typeface="Arial"/>
+              </a:rPr>
+              <a:t>BUILT IN PROTOTYPE</a:t>
+            </a:r>
+          </a:p>
+        </p:txBody>
+      </p:sp>
+      <p:sp>
+        <p:nvSpPr>
+          <p:cNvPr id="7" name="Rounded Rectangle 6"/>
+          <p:cNvSpPr/>
+          <p:nvPr/>
+        </p:nvSpPr>
+        <p:spPr>
+          <a:xfrm>
+            <a:off x="457200" y="1572768"/>
+            <a:ext cx="3749039" cy="4782312"/>
           </a:xfrm>
           <a:prstGeom prst="roundRect">
             <a:avLst>
@@ -6361,13 +6759,69 @@
               </a:spcAft>
             </a:pPr>
             <a:r>
-              <a:rPr sz="1400" b="1" i="0">
+              <a:rPr sz="1250" b="1" i="0">
                 <a:solidFill>
                   <a:srgbClr val="3B4FD8"/>
                 </a:solidFill>
                 <a:latin typeface="Arial"/>
               </a:rPr>
-              <a:t>How investigators trust, check and override it</a:t>
+              <a:t>How an investigator trusts, checks and overrides</a:t>
+            </a:r>
+          </a:p>
+          <a:p>
+            <a:pPr algn="l">
+              <a:lnSpc>
+                <a:spcPct val="100000"/>
+              </a:lnSpc>
+              <a:spcAft>
+                <a:spcPts val="500"/>
+              </a:spcAft>
+            </a:pPr>
+            <a:r>
+              <a:rPr sz="1050" b="1" i="0">
+                <a:solidFill>
+                  <a:srgbClr val="3B4FD8"/>
+                </a:solidFill>
+                <a:latin typeface="Arial"/>
+              </a:rPr>
+              <a:t>AI can: </a:t>
+            </a:r>
+            <a:r>
+              <a:rPr sz="1050" b="0" i="0">
+                <a:solidFill>
+                  <a:srgbClr val="1A1F2B"/>
+                </a:solidFill>
+                <a:latin typeface="Arial"/>
+              </a:rPr>
+              <a:t>rank and explain, recommend an action, draft an escalation, answer questions using tools.</a:t>
+            </a:r>
+          </a:p>
+          <a:p>
+            <a:pPr algn="l">
+              <a:lnSpc>
+                <a:spcPct val="100000"/>
+              </a:lnSpc>
+              <a:spcAft>
+                <a:spcPts val="700"/>
+              </a:spcAft>
+            </a:pPr>
+            <a:r>
+              <a:rPr sz="1050" b="1" i="0">
+                <a:solidFill>
+                  <a:srgbClr val="B42318"/>
+                </a:solidFill>
+                <a:latin typeface="Arial"/>
+              </a:rPr>
+              <a:t>Only a human can: </a:t>
+            </a:r>
+            <a:r>
+              <a:rPr sz="1050" b="0" i="0">
+                <a:solidFill>
+                  <a:srgbClr val="1A1F2B"/>
+                </a:solidFill>
+                <a:latin typeface="Arial"/>
+              </a:rPr>
+              <a:t>clear, escalate, mark fraud, delete a note. Supervisors alone: override a decline, activate a hard rule.</a:t>
             </a:r>
           </a:p>
           <a:p>
@@ -6376,18 +6830,18 @@
                 <a:spcPct val="100000"/>
               </a:lnSpc>
               <a:spcAft>
-                <a:spcPts val="700"/>
+                <a:spcPts val="400"/>
               </a:spcAft>
               <a:buChar char="•"/>
             </a:pPr>
             <a:r>
-              <a:rPr sz="1150" b="0" i="0">
+              <a:rPr sz="1050" b="0" i="0">
                 <a:solidFill>
                   <a:srgbClr val="1A1F2B"/>
                 </a:solidFill>
                 <a:latin typeface="Arial"/>
               </a:rPr>
-              <a:t>Rule score and AI score are shown side by side.</a:t>
+              <a:t>Rule score and AI score side by side</a:t>
             </a:r>
           </a:p>
           <a:p>
@@ -6396,18 +6850,18 @@
                 <a:spcPct val="100000"/>
               </a:lnSpc>
               <a:spcAft>
-                <a:spcPts val="700"/>
+                <a:spcPts val="400"/>
               </a:spcAft>
               <a:buChar char="•"/>
             </a:pPr>
             <a:r>
-              <a:rPr sz="1150" b="0" i="0">
+              <a:rPr sz="1050" b="0" i="0">
                 <a:solidFill>
                   <a:srgbClr val="1A1F2B"/>
                 </a:solidFill>
                 <a:latin typeface="Arial"/>
               </a:rPr>
-              <a:t>Every indicator cites a field and value. Accept ✓ or reject ✗; rejected findings are not re-asserted.</a:t>
+              <a:t>Every indicator cites field = value; accept ✓ or reject ✗, and a rejected finding is not re-asserted</a:t>
             </a:r>
           </a:p>
           <a:p>
@@ -6416,18 +6870,18 @@
                 <a:spcPct val="100000"/>
               </a:lnSpc>
               <a:spcAft>
-                <a:spcPts val="700"/>
+                <a:spcPts val="400"/>
               </a:spcAft>
               <a:buChar char="•"/>
             </a:pPr>
             <a:r>
-              <a:rPr sz="1150" b="0" i="0">
+              <a:rPr sz="1050" b="0" i="0">
                 <a:solidFill>
                   <a:srgbClr val="1A1F2B"/>
                 </a:solidFill>
                 <a:latin typeface="Arial"/>
               </a:rPr>
-              <a:t>Guardrail removals and the full agent trace are visible.</a:t>
+              <a:t>Full agent trace and guardrail removals visible</a:t>
             </a:r>
           </a:p>
           <a:p>
@@ -6436,18 +6890,18 @@
                 <a:spcPct val="100000"/>
               </a:lnSpc>
               <a:spcAft>
-                <a:spcPts val="700"/>
+                <a:spcPts val="400"/>
               </a:spcAft>
               <a:buChar char="•"/>
             </a:pPr>
             <a:r>
-              <a:rPr sz="1150" b="0" i="0">
+              <a:rPr sz="1050" b="0" i="0">
                 <a:solidFill>
                   <a:srgbClr val="1A1F2B"/>
                 </a:solidFill>
                 <a:latin typeface="Arial"/>
               </a:rPr>
-              <a:t>A note changes the next assessment. Deleting it removes it from the AI, the chat and the audit text.</a:t>
+              <a:t>A note changes the next assessment; deleting it purges it everywhere</a:t>
             </a:r>
           </a:p>
           <a:p>
@@ -6456,18 +6910,18 @@
                 <a:spcPct val="100000"/>
               </a:lnSpc>
               <a:spcAft>
-                <a:spcPts val="700"/>
+                <a:spcPts val="400"/>
               </a:spcAft>
               <a:buChar char="•"/>
             </a:pPr>
             <a:r>
-              <a:rPr sz="1150" b="0" i="0">
+              <a:rPr sz="1050" b="0" i="0">
                 <a:solidFill>
                   <a:srgbClr val="1A1F2B"/>
                 </a:solidFill>
                 <a:latin typeface="Arial"/>
               </a:rPr>
-              <a:t>Every clear, escalation and override needs a reason and is audited. The AI never changes a status.</a:t>
+              <a:t>Every action needs a reason and lands in the audit log</a:t>
             </a:r>
           </a:p>
           <a:p>
@@ -6476,18 +6930,18 @@
                 <a:spcPct val="100000"/>
               </a:lnSpc>
               <a:spcAft>
-                <a:spcPts val="700"/>
+                <a:spcPts val="400"/>
               </a:spcAft>
               <a:buChar char="•"/>
             </a:pPr>
             <a:r>
-              <a:rPr sz="1150" b="0" i="0">
+              <a:rPr sz="1050" b="0" i="0">
                 <a:solidFill>
                   <a:srgbClr val="1A1F2B"/>
                 </a:solidFill>
                 <a:latin typeface="Arial"/>
               </a:rPr>
-              <a:t>Bulk clear previews what is blocked, and why.</a:t>
+              <a:t>Bulk clear previews what is blocked, and why</a:t>
             </a:r>
           </a:p>
           <a:p>
@@ -6496,72 +6950,94 @@
                 <a:spcPct val="100000"/>
               </a:lnSpc>
               <a:spcAft>
-                <a:spcPts val="700"/>
+                <a:spcPts val="0"/>
               </a:spcAft>
               <a:buChar char="•"/>
             </a:pPr>
             <a:r>
-              <a:rPr sz="1150" b="0" i="0">
+              <a:rPr sz="1050" b="0" i="0">
                 <a:solidFill>
                   <a:srgbClr val="1A1F2B"/>
                 </a:solidFill>
                 <a:latin typeface="Arial"/>
               </a:rPr>
-              <a:t>Supervisors approve or return escalations, override blocklist declines and activate hard rules; investigators can only propose.</a:t>
-            </a:r>
-          </a:p>
-          <a:p>
-            <a:pPr algn="l" marL="137160" indent="-137160">
-              <a:lnSpc>
-                <a:spcPct val="100000"/>
-              </a:lnSpc>
-              <a:spcAft>
-                <a:spcPts val="700"/>
-              </a:spcAft>
-              <a:buChar char="•"/>
-            </a:pPr>
-            <a:r>
-              <a:rPr sz="1150" b="0" i="0">
-                <a:solidFill>
-                  <a:srgbClr val="1A1F2B"/>
-                </a:solidFill>
-                <a:latin typeface="Arial"/>
-              </a:rPr>
-              <a:t>Rules tab: draft, backtest with impact preview, then save or run in shadow.</a:t>
-            </a:r>
-          </a:p>
-          <a:p>
-            <a:pPr algn="l" marL="137160" indent="-137160">
-              <a:lnSpc>
-                <a:spcPct val="100000"/>
-              </a:lnSpc>
-              <a:spcAft>
-                <a:spcPts val="0"/>
-              </a:spcAft>
-              <a:buChar char="•"/>
-            </a:pPr>
-            <a:r>
-              <a:rPr sz="1150" b="0" i="0">
-                <a:solidFill>
-                  <a:srgbClr val="1A1F2B"/>
-                </a:solidFill>
-                <a:latin typeface="Arial"/>
-              </a:rPr>
-              <a:t>'Mark as FRAUD' teaches the system: lookalikes are flagged and clearing them is blocked.</a:t>
-            </a:r>
-          </a:p>
-        </p:txBody>
-      </p:sp>
-      <p:sp>
-        <p:nvSpPr>
-          <p:cNvPr id="7" name="Rounded Rectangle 6"/>
+              <a:t>“Mark as FRAUD” teaches the system: lookalikes get flagged (R17)</a:t>
+            </a:r>
+          </a:p>
+        </p:txBody>
+      </p:sp>
+      <p:sp>
+        <p:nvSpPr>
+          <p:cNvPr id="8" name="Rounded Rectangle 7"/>
           <p:cNvSpPr/>
           <p:nvPr/>
         </p:nvSpPr>
         <p:spPr>
           <a:xfrm>
-            <a:off x="4251960" y="1298448"/>
-            <a:ext cx="3685032" cy="5056632"/>
+            <a:off x="4343400" y="1298448"/>
+            <a:ext cx="1371600" cy="219456"/>
+          </a:xfrm>
+          <a:prstGeom prst="roundRect">
+            <a:avLst>
+              <a:gd name="adj" fmla="val 40000"/>
+            </a:avLst>
+          </a:prstGeom>
+          <a:solidFill>
+            <a:srgbClr val="3B4FD8"/>
+          </a:solidFill>
+          <a:ln>
+            <a:noFill/>
+          </a:ln>
+          <a:effectLst/>
+        </p:spPr>
+        <p:style>
+          <a:lnRef idx="1">
+            <a:schemeClr val="accent1"/>
+          </a:lnRef>
+          <a:fillRef idx="3">
+            <a:schemeClr val="accent1"/>
+          </a:fillRef>
+          <a:effectRef idx="2">
+            <a:schemeClr val="accent1"/>
+          </a:effectRef>
+          <a:fontRef idx="minor">
+            <a:schemeClr val="lt1"/>
+          </a:fontRef>
+        </p:style>
+        <p:txBody>
+          <a:bodyPr rtlCol="0" anchor="ctr" wrap="square" lIns="36576" tIns="0" rIns="36576" bIns="0"/>
+          <a:lstStyle/>
+          <a:p>
+            <a:pPr algn="ctr">
+              <a:lnSpc>
+                <a:spcPct val="100000"/>
+              </a:lnSpc>
+              <a:spcAft>
+                <a:spcPts val="0"/>
+              </a:spcAft>
+            </a:pPr>
+            <a:r>
+              <a:rPr sz="850" b="1" i="0">
+                <a:solidFill>
+                  <a:srgbClr val="FFFFFF"/>
+                </a:solidFill>
+                <a:latin typeface="Arial"/>
+              </a:rPr>
+              <a:t>BUILT IN PROTOTYPE</a:t>
+            </a:r>
+          </a:p>
+        </p:txBody>
+      </p:sp>
+      <p:sp>
+        <p:nvSpPr>
+          <p:cNvPr id="9" name="Rounded Rectangle 8"/>
+          <p:cNvSpPr/>
+          <p:nvPr/>
+        </p:nvSpPr>
+        <p:spPr>
+          <a:xfrm>
+            <a:off x="4343400" y="1572768"/>
+            <a:ext cx="3749039" cy="4782312"/>
           </a:xfrm>
           <a:prstGeom prst="roundRect">
             <a:avLst>
@@ -6605,187 +7081,260 @@
               </a:spcAft>
             </a:pPr>
             <a:r>
-              <a:rPr sz="1400" b="1" i="0">
+              <a:rPr sz="1250" b="1" i="0">
                 <a:solidFill>
                   <a:srgbClr val="3B4FD8"/>
                 </a:solidFill>
                 <a:latin typeface="Arial"/>
               </a:rPr>
-              <a:t>Trade-offs and risks</a:t>
-            </a:r>
-          </a:p>
-          <a:p>
-            <a:pPr algn="l" marL="137160" indent="-137160">
-              <a:lnSpc>
-                <a:spcPct val="100000"/>
-              </a:lnSpc>
-              <a:spcAft>
-                <a:spcPts val="700"/>
-              </a:spcAft>
-              <a:buChar char="•"/>
-            </a:pPr>
-            <a:r>
-              <a:rPr sz="1150" b="0" i="0">
+              <a:t>Trade-offs and risks I see</a:t>
+            </a:r>
+          </a:p>
+          <a:p>
+            <a:pPr algn="l">
+              <a:lnSpc>
+                <a:spcPct val="100000"/>
+              </a:lnSpc>
+              <a:spcAft>
+                <a:spcPts val="500"/>
+              </a:spcAft>
+            </a:pPr>
+            <a:r>
+              <a:rPr sz="1050" b="1" i="0">
                 <a:solidFill>
                   <a:srgbClr val="1A1F2B"/>
                 </a:solidFill>
                 <a:latin typeface="Arial"/>
               </a:rPr>
-              <a:t>Accuracy: no labels. Backtests use synthetic labels (leave-one-out, so a rule does not grade itself): they show agreement, not fraud.</a:t>
-            </a:r>
-          </a:p>
-          <a:p>
-            <a:pPr algn="l" marL="137160" indent="-137160">
-              <a:lnSpc>
-                <a:spcPct val="100000"/>
-              </a:lnSpc>
-              <a:spcAft>
-                <a:spcPts val="700"/>
-              </a:spcAft>
-              <a:buChar char="•"/>
-            </a:pPr>
-            <a:r>
-              <a:rPr sz="1150" b="0" i="0">
+              <a:t>Accuracy. </a:t>
+            </a:r>
+            <a:r>
+              <a:rPr sz="1050" b="0" i="0">
                 <a:solidFill>
                   <a:srgbClr val="1A1F2B"/>
                 </a:solidFill>
                 <a:latin typeface="Arial"/>
               </a:rPr>
-              <a:t>Cost: the crew uses fewer tokens but more reference dollars ($0.44 vs $0.12) because of the strong-tier verifier.</a:t>
-            </a:r>
-          </a:p>
-          <a:p>
-            <a:pPr algn="l" marL="137160" indent="-137160">
-              <a:lnSpc>
-                <a:spcPct val="100000"/>
-              </a:lnSpc>
-              <a:spcAft>
-                <a:spcPts val="700"/>
-              </a:spcAft>
-              <a:buChar char="•"/>
-            </a:pPr>
-            <a:r>
-              <a:rPr sz="1150" b="0" i="0">
+              <a:t>No labels, so no accuracy claim. Backtests use synthetic labels (leave-one-out) and measure agreement, not fraud.</a:t>
+            </a:r>
+          </a:p>
+          <a:p>
+            <a:pPr algn="l">
+              <a:lnSpc>
+                <a:spcPct val="100000"/>
+              </a:lnSpc>
+              <a:spcAft>
+                <a:spcPts val="500"/>
+              </a:spcAft>
+            </a:pPr>
+            <a:r>
+              <a:rPr sz="1050" b="1" i="0">
+                <a:solidFill>
+                  <a:srgbClr val="B42318"/>
+                </a:solidFill>
+                <a:latin typeface="Arial"/>
+              </a:rPr>
+              <a:t>False negatives. </a:t>
+            </a:r>
+            <a:r>
+              <a:rPr sz="1050" b="0" i="0">
                 <a:solidFill>
                   <a:srgbClr val="1A1F2B"/>
                 </a:solidFill>
                 <a:latin typeface="Arial"/>
               </a:rPr>
-              <a:t>Latency: about 20 s per call on free models.</a:t>
-            </a:r>
-          </a:p>
-          <a:p>
-            <a:pPr algn="l" marL="137160" indent="-137160">
-              <a:lnSpc>
-                <a:spcPct val="100000"/>
-              </a:lnSpc>
-              <a:spcAft>
-                <a:spcPts val="700"/>
-              </a:spcAft>
-              <a:buChar char="•"/>
-            </a:pPr>
-            <a:r>
-              <a:rPr sz="1150" b="0" i="0">
+              <a:t>The costliest risk; only discovered misses can be measured. Guardrails stop the AI clearing anything risky, but do not find what the rules missed.</a:t>
+            </a:r>
+          </a:p>
+          <a:p>
+            <a:pPr algn="l">
+              <a:lnSpc>
+                <a:spcPct val="100000"/>
+              </a:lnSpc>
+              <a:spcAft>
+                <a:spcPts val="500"/>
+              </a:spcAft>
+            </a:pPr>
+            <a:r>
+              <a:rPr sz="1050" b="1" i="0">
                 <a:solidFill>
                   <a:srgbClr val="1A1F2B"/>
                 </a:solidFill>
                 <a:latin typeface="Arial"/>
               </a:rPr>
-              <a:t>Trust: the prose can still be subtly wrong even when every cited field is right.</a:t>
-            </a:r>
-          </a:p>
-          <a:p>
-            <a:pPr algn="l" marL="137160" indent="-137160">
-              <a:lnSpc>
-                <a:spcPct val="100000"/>
-              </a:lnSpc>
-              <a:spcAft>
-                <a:spcPts val="700"/>
-              </a:spcAft>
-              <a:buChar char="•"/>
-            </a:pPr>
-            <a:r>
-              <a:rPr sz="1150" b="0" i="0">
+              <a:t>Cost and latency. </a:t>
+            </a:r>
+            <a:r>
+              <a:rPr sz="1050" b="0" i="0">
                 <a:solidFill>
                   <a:srgbClr val="1A1F2B"/>
                 </a:solidFill>
                 <a:latin typeface="Arial"/>
               </a:rPr>
-              <a:t>Abuse: injection notes, bulk clear, over-broad blocklist entries (confirmation needed above 25% of the queue).</a:t>
-            </a:r>
-          </a:p>
-          <a:p>
-            <a:pPr algn="l" marL="137160" indent="-137160">
-              <a:lnSpc>
-                <a:spcPct val="100000"/>
-              </a:lnSpc>
-              <a:spcAft>
-                <a:spcPts val="700"/>
-              </a:spcAft>
-              <a:buChar char="•"/>
-            </a:pPr>
-            <a:r>
-              <a:rPr sz="1150" b="0" i="0">
+              <a:t>Fewer tokens, more reference dollars ($0.44 vs $0.12). About 20 s per call; free models rate-limit, so some cases show “LLM unavailable”.</a:t>
+            </a:r>
+          </a:p>
+          <a:p>
+            <a:pPr algn="l">
+              <a:lnSpc>
+                <a:spcPct val="100000"/>
+              </a:lnSpc>
+              <a:spcAft>
+                <a:spcPts val="500"/>
+              </a:spcAft>
+            </a:pPr>
+            <a:r>
+              <a:rPr sz="1050" b="1" i="0">
                 <a:solidFill>
                   <a:srgbClr val="1A1F2B"/>
                 </a:solidFill>
                 <a:latin typeface="Arial"/>
               </a:rPr>
-              <a:t>Fairness: distance and weekend signals can proxy for rural or shift-work providers.</a:t>
-            </a:r>
-          </a:p>
-          <a:p>
-            <a:pPr algn="l" marL="137160" indent="-137160">
-              <a:lnSpc>
-                <a:spcPct val="100000"/>
-              </a:lnSpc>
-              <a:spcAft>
-                <a:spcPts val="700"/>
-              </a:spcAft>
-              <a:buChar char="•"/>
-            </a:pPr>
-            <a:r>
-              <a:rPr sz="1150" b="0" i="0">
+              <a:t>Trust. </a:t>
+            </a:r>
+            <a:r>
+              <a:rPr sz="1050" b="0" i="0">
                 <a:solidFill>
                   <a:srgbClr val="1A1F2B"/>
                 </a:solidFill>
                 <a:latin typeface="Arial"/>
               </a:rPr>
-              <a:t>False negatives are the costliest risk, and only discovered misses can be measured.</a:t>
-            </a:r>
-          </a:p>
-          <a:p>
-            <a:pPr algn="l" marL="137160" indent="-137160">
+              <a:t>Cited fields are verified; the prose is not. It can still be subtly wrong.</a:t>
+            </a:r>
+          </a:p>
+          <a:p>
+            <a:pPr algn="l">
+              <a:lnSpc>
+                <a:spcPct val="100000"/>
+              </a:lnSpc>
+              <a:spcAft>
+                <a:spcPts val="500"/>
+              </a:spcAft>
+            </a:pPr>
+            <a:r>
+              <a:rPr sz="1050" b="1" i="0">
+                <a:solidFill>
+                  <a:srgbClr val="1A1F2B"/>
+                </a:solidFill>
+                <a:latin typeface="Arial"/>
+              </a:rPr>
+              <a:t>Abuse. </a:t>
+            </a:r>
+            <a:r>
+              <a:rPr sz="1050" b="0" i="0">
+                <a:solidFill>
+                  <a:srgbClr val="1A1F2B"/>
+                </a:solidFill>
+                <a:latin typeface="Arial"/>
+              </a:rPr>
+              <a:t>Notes are untrusted (injection tests pass); bulk clear is guarded; blocklist entries covering over 25% of the queue need confirmation.</a:t>
+            </a:r>
+          </a:p>
+          <a:p>
+            <a:pPr algn="l">
               <a:lnSpc>
                 <a:spcPct val="100000"/>
               </a:lnSpc>
               <a:spcAft>
                 <a:spcPts val="0"/>
               </a:spcAft>
-              <a:buChar char="•"/>
-            </a:pPr>
-            <a:r>
-              <a:rPr sz="1150" b="0" i="0">
+            </a:pPr>
+            <a:r>
+              <a:rPr sz="1050" b="1" i="0">
                 <a:solidFill>
                   <a:srgbClr val="1A1F2B"/>
                 </a:solidFill>
                 <a:latin typeface="Arial"/>
               </a:rPr>
-              <a:t>My own evals found: the challenger rates every case 'medium', and confidence barely separates contested cases.</a:t>
-            </a:r>
-          </a:p>
-        </p:txBody>
-      </p:sp>
-      <p:sp>
-        <p:nvSpPr>
-          <p:cNvPr id="8" name="Rounded Rectangle 7"/>
+              <a:t>Fairness. </a:t>
+            </a:r>
+            <a:r>
+              <a:rPr sz="1050" b="0" i="0">
+                <a:solidFill>
+                  <a:srgbClr val="1A1F2B"/>
+                </a:solidFill>
+                <a:latin typeface="Arial"/>
+              </a:rPr>
+              <a:t>Distance and weekend signals can proxy for rural or shift-work providers.</a:t>
+            </a:r>
+          </a:p>
+        </p:txBody>
+      </p:sp>
+      <p:sp>
+        <p:nvSpPr>
+          <p:cNvPr id="10" name="Rounded Rectangle 9"/>
           <p:cNvSpPr/>
           <p:nvPr/>
         </p:nvSpPr>
         <p:spPr>
           <a:xfrm>
-            <a:off x="8046720" y="1298448"/>
-            <a:ext cx="3685032" cy="5056632"/>
+            <a:off x="8229600" y="1298448"/>
+            <a:ext cx="2011680" cy="219456"/>
+          </a:xfrm>
+          <a:prstGeom prst="roundRect">
+            <a:avLst>
+              <a:gd name="adj" fmla="val 40000"/>
+            </a:avLst>
+          </a:prstGeom>
+          <a:solidFill>
+            <a:srgbClr val="FFFFFF"/>
+          </a:solidFill>
+          <a:ln w="12700">
+            <a:solidFill>
+              <a:srgbClr val="5B6478"/>
+            </a:solidFill>
+            <a:prstDash val="dash"/>
+          </a:ln>
+          <a:effectLst/>
+        </p:spPr>
+        <p:style>
+          <a:lnRef idx="1">
+            <a:schemeClr val="accent1"/>
+          </a:lnRef>
+          <a:fillRef idx="3">
+            <a:schemeClr val="accent1"/>
+          </a:fillRef>
+          <a:effectRef idx="2">
+            <a:schemeClr val="accent1"/>
+          </a:effectRef>
+          <a:fontRef idx="minor">
+            <a:schemeClr val="lt1"/>
+          </a:fontRef>
+        </p:style>
+        <p:txBody>
+          <a:bodyPr rtlCol="0" anchor="ctr" wrap="square" lIns="36576" tIns="0" rIns="36576" bIns="0"/>
+          <a:lstStyle/>
+          <a:p>
+            <a:pPr algn="ctr">
+              <a:lnSpc>
+                <a:spcPct val="100000"/>
+              </a:lnSpc>
+              <a:spcAft>
+                <a:spcPts val="0"/>
+              </a:spcAft>
+            </a:pPr>
+            <a:r>
+              <a:rPr sz="850" b="1" i="0">
+                <a:solidFill>
+                  <a:srgbClr val="5B6478"/>
+                </a:solidFill>
+                <a:latin typeface="Arial"/>
+              </a:rPr>
+              <a:t>PRODUCTION PATH: NOT BUILT</a:t>
+            </a:r>
+          </a:p>
+        </p:txBody>
+      </p:sp>
+      <p:sp>
+        <p:nvSpPr>
+          <p:cNvPr id="11" name="Rounded Rectangle 10"/>
+          <p:cNvSpPr/>
+          <p:nvPr/>
+        </p:nvSpPr>
+        <p:spPr>
+          <a:xfrm>
+            <a:off x="8229600" y="1572768"/>
+            <a:ext cx="3502152" cy="4782312"/>
           </a:xfrm>
           <a:prstGeom prst="roundRect">
             <a:avLst>
@@ -6793,10 +7342,13 @@
             </a:avLst>
           </a:prstGeom>
           <a:solidFill>
-            <a:srgbClr val="ECF7F1"/>
+            <a:srgbClr val="FFFFFF"/>
           </a:solidFill>
-          <a:ln>
-            <a:noFill/>
+          <a:ln w="12700">
+            <a:solidFill>
+              <a:srgbClr val="5B6478"/>
+            </a:solidFill>
+            <a:prstDash val="dash"/>
           </a:ln>
           <a:effectLst/>
         </p:spPr>
@@ -6827,7 +7379,7 @@
               </a:spcAft>
             </a:pPr>
             <a:r>
-              <a:rPr sz="1400" b="1" i="0">
+              <a:rPr sz="1250" b="1" i="0">
                 <a:solidFill>
                   <a:srgbClr val="3B4FD8"/>
                 </a:solidFill>
@@ -6837,103 +7389,87 @@
             </a:r>
           </a:p>
           <a:p>
-            <a:pPr algn="l" marL="137160" indent="-137160">
-              <a:lnSpc>
-                <a:spcPct val="100000"/>
-              </a:lnSpc>
-              <a:spcAft>
-                <a:spcPts val="700"/>
-              </a:spcAft>
-              <a:buChar char="•"/>
-            </a:pPr>
-            <a:r>
-              <a:rPr sz="1150" b="0" i="0">
+            <a:pPr algn="l">
+              <a:lnSpc>
+                <a:spcPct val="100000"/>
+              </a:lnSpc>
+              <a:spcAft>
+                <a:spcPts val="600"/>
+              </a:spcAft>
+            </a:pPr>
+            <a:r>
+              <a:rPr sz="1050" b="1" i="0">
                 <a:solidFill>
                   <a:srgbClr val="1A1F2B"/>
                 </a:solidFill>
                 <a:latin typeface="Arial"/>
               </a:rPr>
-              <a:t>False-negative safety net: miss-rate tracking from confirmed outcomes; a look-back that reopens cleared lookalikes; an independent adversarial reviewer; audited sampling with a statistical bound.</a:t>
-            </a:r>
-          </a:p>
-          <a:p>
-            <a:pPr algn="l" marL="137160" indent="-137160">
-              <a:lnSpc>
-                <a:spcPct val="100000"/>
-              </a:lnSpc>
-              <a:spcAft>
-                <a:spcPts val="700"/>
-              </a:spcAft>
-              <a:buChar char="•"/>
-            </a:pPr>
-            <a:r>
-              <a:rPr sz="1150" b="0" i="0">
+              <a:t>1  False-negative safety net. </a:t>
+            </a:r>
+            <a:r>
+              <a:rPr sz="1050" b="0" i="0">
                 <a:solidFill>
                   <a:srgbClr val="1A1F2B"/>
                 </a:solidFill>
                 <a:latin typeface="Arial"/>
               </a:rPr>
-              <a:t>Anomaly detector: prototyped, deferred because it is unstable at 50 cases.</a:t>
-            </a:r>
-          </a:p>
-          <a:p>
-            <a:pPr algn="l" marL="137160" indent="-137160">
-              <a:lnSpc>
-                <a:spcPct val="100000"/>
-              </a:lnSpc>
-              <a:spcAft>
-                <a:spcPts val="700"/>
-              </a:spcAft>
-              <a:buChar char="•"/>
-            </a:pPr>
-            <a:r>
-              <a:rPr sz="1150" b="0" i="0">
+              <a:t>Miss-rate tracking from confirmed outcomes; a look-back that reopens cleared lookalikes; an independent adversarial reviewer; audit sampling with a statistical bound.</a:t>
+            </a:r>
+          </a:p>
+          <a:p>
+            <a:pPr algn="l">
+              <a:lnSpc>
+                <a:spcPct val="100000"/>
+              </a:lnSpc>
+              <a:spcAft>
+                <a:spcPts val="600"/>
+              </a:spcAft>
+            </a:pPr>
+            <a:r>
+              <a:rPr sz="1050" b="1" i="0">
                 <a:solidFill>
                   <a:srgbClr val="1A1F2B"/>
                 </a:solidFill>
                 <a:latin typeface="Arial"/>
               </a:rPr>
-              <a:t>Re-fit weights and thresholds from confirmed outcomes.</a:t>
-            </a:r>
-          </a:p>
-          <a:p>
-            <a:pPr algn="l" marL="137160" indent="-137160">
-              <a:lnSpc>
-                <a:spcPct val="100000"/>
-              </a:lnSpc>
-              <a:spcAft>
-                <a:spcPts val="700"/>
-              </a:spcAft>
-              <a:buChar char="•"/>
-            </a:pPr>
-            <a:r>
-              <a:rPr sz="1150" b="0" i="0">
+              <a:t>2  Learn from outcomes. </a:t>
+            </a:r>
+            <a:r>
+              <a:rPr sz="1050" b="0" i="0">
                 <a:solidFill>
                   <a:srgbClr val="1A1F2B"/>
                 </a:solidFill>
                 <a:latin typeface="Arial"/>
               </a:rPr>
-              <a:t>A provider and member graph; a labelled backtest.</a:t>
-            </a:r>
-          </a:p>
-          <a:p>
-            <a:pPr algn="l" marL="137160" indent="-137160">
-              <a:lnSpc>
-                <a:spcPct val="100000"/>
-              </a:lnSpc>
-              <a:spcAft>
-                <a:spcPts val="700"/>
-              </a:spcAft>
-              <a:buChar char="•"/>
-            </a:pPr>
-            <a:r>
-              <a:rPr sz="1150" b="0" i="0">
+              <a:t>Re-fit weights and thresholds from confirmed fraud.</a:t>
+            </a:r>
+          </a:p>
+          <a:p>
+            <a:pPr algn="l">
+              <a:lnSpc>
+                <a:spcPct val="100000"/>
+              </a:lnSpc>
+              <a:spcAft>
+                <a:spcPts val="600"/>
+              </a:spcAft>
+            </a:pPr>
+            <a:r>
+              <a:rPr sz="1050" b="1" i="0">
                 <a:solidFill>
                   <a:srgbClr val="1A1F2B"/>
                 </a:solidFill>
                 <a:latin typeface="Arial"/>
               </a:rPr>
-              <a:t>Four-eyes on large bulk clears; a streaming UI.</a:t>
+              <a:t>3  Provider / member graph </a:t>
+            </a:r>
+            <a:r>
+              <a:rPr sz="1050" b="0" i="0">
+                <a:solidFill>
+                  <a:srgbClr val="1A1F2B"/>
+                </a:solidFill>
+                <a:latin typeface="Arial"/>
+              </a:rPr>
+              <a:t>and a labelled backtest, once real IDs and labels exist.</a:t>
             </a:r>
           </a:p>
           <a:p>
@@ -6942,17 +7478,45 @@
                 <a:spcPct val="100000"/>
               </a:lnSpc>
               <a:spcAft>
+                <a:spcPts val="1000"/>
+              </a:spcAft>
+            </a:pPr>
+            <a:r>
+              <a:rPr sz="1050" b="1" i="0">
+                <a:solidFill>
+                  <a:srgbClr val="1A1F2B"/>
+                </a:solidFill>
+                <a:latin typeface="Arial"/>
+              </a:rPr>
+              <a:t>4  Four-eyes </a:t>
+            </a:r>
+            <a:r>
+              <a:rPr sz="1050" b="0" i="0">
+                <a:solidFill>
+                  <a:srgbClr val="1A1F2B"/>
+                </a:solidFill>
+                <a:latin typeface="Arial"/>
+              </a:rPr>
+              <a:t>on large bulk clears; streaming UI.</a:t>
+            </a:r>
+          </a:p>
+          <a:p>
+            <a:pPr algn="l">
+              <a:lnSpc>
+                <a:spcPct val="100000"/>
+              </a:lnSpc>
+              <a:spcAft>
                 <a:spcPts val="0"/>
               </a:spcAft>
             </a:pPr>
             <a:r>
-              <a:rPr sz="1150" b="0" i="0">
+              <a:rPr sz="1000" b="0" i="0">
                 <a:solidFill>
                   <a:srgbClr val="5B6478"/>
                 </a:solidFill>
                 <a:latin typeface="Arial"/>
               </a:rPr>
-              <a:t>Deliberately cut: auth, deployment, enrichment, model training.</a:t>
+              <a:t>Prototyped, then deferred: a statistical anomaly detector. On 50 cases its flagged set changed with the random seed, so I would not ship it.</a:t>
             </a:r>
           </a:p>
         </p:txBody>

</xml_diff>

<commit_message>
Slide 1: scope and system overview only; treat notes as trusted expert evidence
Removes the triage/lane breakdown from slide 1 (it belongs on slide 2) and
replaces it with a one-line system summary, a 3x3 grid of what was built, and
four left-out items each with its reason.

Co-Authored-By: Claude Opus 5 <noreply@anthropic.com>
</commit_message>
<xml_diff>
--- a/docs/Writeup.pptx
+++ b/docs/Writeup.pptx
@@ -505,7 +505,7 @@
           <a:lstStyle/>
           <a:p>
             <a:r>
-              <a:t>THE USER is a fraud investigator and their supervisor. Every morning an engine hands them a queue of referrals, and most of those turn out benign. Today they paste a claim number into a legacy tool and read nine signals a case, one case at a time. The cost is not the fraud they find, it is the hours spent on the cases that were never fraud.</a:t>
+              <a:t>THE USER is a fraud investigator and their supervisor. Every morning an engine hands them a queue of referrals, and most of those turn out benign. Today they paste a claim number into a legacy tool and read nine signals a case, one case at a time. The cost is not the fraud they find, it is the hours spent on cases that were never fraud.</a:t>
             </a:r>
           </a:p>
           <a:p/>
@@ -517,13 +517,19 @@
           <a:p/>
           <a:p>
             <a:r>
-              <a:t>THE DATA SHAPED THE BUILD. The 50-case sample splits three ways: 8 cases extreme on every signal, 9 genuinely ambiguous, 33 clean. That split is the whole product thesis: deterministic rules are enough for the 8 and the 33, so the expensive reasoning belongs to the 9. Two patterns no row-by-row engine can see: three cases trip no flag at all yet carry five elevated signals, and one claim number (LTC-2034786) sits on both a clean case and a critical one.</a:t>
+              <a:t>THE SYSTEM IN ONE BREATH: it ingests the referral queue, scores every case with rules calibrated from the data, has an agent crew reason over the cases that are genuinely unclear, and hands the investigator a ranked queue where each case carries a summary, cited evidence, a risk level and a recommended action — with every AI step and every human decision recorded. Slide 2 opens up how that reasoning works.</a:t>
             </a:r>
           </a:p>
           <a:p/>
           <a:p>
             <a:r>
-              <a:t>WHAT I CUT AND WHY: auth, multi-tenancy and deployment are explicitly out of scope in the brief. I did not train a model because the data has no fraud labels, so any accuracy number would be invented. A provider/member graph needs IDs the CSV does not contain; the code supports them the day a dataset does.</a:t>
+              <a:t>WHAT I BUILT is a narrow surface finished properly rather than a wide one half-done: the briefing an investigator lands on, the case view they work in, the bulk actions that clear the benign majority safely, and the two governance surfaces — Rules and Blocklist — that let the team change the system's behaviour without an engineer.</a:t>
+            </a:r>
+          </a:p>
+          <a:p/>
+          <a:p>
+            <a:r>
+              <a:t>WHAT I CUT AND WHY: auth, multi-tenancy and deployment are explicitly out of scope in the brief, so investigator and supervisor are personas you switch between. I did not train a model because the data carries no fraud labels, so any accuracy number would be invented. A provider/member graph needs IDs the CSV does not contain — the linkage code is written and works on claim number today. External enrichment was interesting but not the core of the AI experience.</a:t>
             </a:r>
           </a:p>
         </p:txBody>
@@ -699,7 +705,7 @@
           <a:p/>
           <a:p>
             <a:r>
-              <a:t>ABUSE AND FAIRNESS. Notes are untrusted input and injection tests pass. Bulk clear previews what it cannot touch. A blocklist entry covering more than a quarter of the queue demands explicit confirmation. On fairness, distance and weekend-billing signals can proxy for rural or shift-work providers — worth auditing before any real deployment.</a:t>
+              <a:t>ABUSE AND FAIRNESS. Bulk clear previews what it cannot touch. A blocklist entry covering more than a quarter of the queue demands explicit confirmation. On fairness, distance and weekend-billing signals can proxy for rural or shift-work providers — worth auditing before any real deployment.</a:t>
             </a:r>
           </a:p>
           <a:p/>
@@ -793,7 +799,7 @@
           <a:p/>
           <a:p>
             <a:r>
-              <a:t>NOTES ARE THE STEERING WHEEL. An investigator's note changes the next assessment — the case is marked stale the moment its inputs change — and the chatbot can quote it. Deleting a note purges it everywhere: assessments, chat history, related-case context. Notes are also treated as untrusted text, so an instruction hidden inside one is not obeyed; that is covered by passing injection tests.</a:t>
+              <a:t>NOTES ARE THE STEERING WHEEL. An investigator's note changes the next assessment — the case is marked stale the moment its inputs change — and the chatbot can quote it. Deleting a note purges it everywhere: assessments, chat history, related-case context. A note is trusted expert evidence and is weighed like any other signal, inside the same guardrails; knowledge that should apply to every case is promoted to a rule in the Rules tab or the Blocklist.</a:t>
             </a:r>
           </a:p>
           <a:p/>
@@ -3848,7 +3854,7 @@
                 </a:solidFill>
                 <a:latin typeface="Arial"/>
               </a:rPr>
-              <a:t>Investigators should open to a queue that is already triaged</a:t>
+              <a:t>A junior investigator that works the queue before a human opens it</a:t>
             </a:r>
           </a:p>
         </p:txBody>
@@ -3890,7 +3896,7 @@
                 </a:solidFill>
                 <a:latin typeface="Arial"/>
               </a:rPr>
-              <a:t>The user · the job to be done · what I built and what I left out</a:t>
+              <a:t>The user · the job to be done · what I built, what I left out, and why</a:t>
             </a:r>
           </a:p>
         </p:txBody>
@@ -4032,7 +4038,7 @@
         <p:spPr>
           <a:xfrm>
             <a:off x="502920" y="1371600"/>
-            <a:ext cx="5532120" cy="1298448"/>
+            <a:ext cx="5532120" cy="1225296"/>
           </a:xfrm>
           <a:prstGeom prst="roundRect">
             <a:avLst>
@@ -4093,7 +4099,7 @@
               </a:spcAft>
             </a:pPr>
             <a:r>
-              <a:rPr sz="1250" b="0">
+              <a:rPr sz="1200" b="0">
                 <a:solidFill>
                   <a:srgbClr val="0F172A"/>
                 </a:solidFill>
@@ -4113,7 +4119,7 @@
         <p:spPr>
           <a:xfrm>
             <a:off x="6144768" y="1371600"/>
-            <a:ext cx="5541264" cy="1298448"/>
+            <a:ext cx="5541264" cy="1225296"/>
           </a:xfrm>
           <a:prstGeom prst="roundRect">
             <a:avLst>
@@ -4174,7 +4180,7 @@
               </a:spcAft>
             </a:pPr>
             <a:r>
-              <a:rPr sz="1250" b="0">
+              <a:rPr sz="1200" b="0">
                 <a:solidFill>
                   <a:srgbClr val="0F172A"/>
                 </a:solidFill>
@@ -4187,299 +4193,14 @@
       </p:sp>
       <p:sp>
         <p:nvSpPr>
-          <p:cNvPr id="9" name="TextBox 8"/>
-          <p:cNvSpPr txBox="1"/>
-          <p:nvPr/>
-        </p:nvSpPr>
-        <p:spPr>
-          <a:xfrm>
-            <a:off x="502920" y="2871216"/>
-            <a:ext cx="5486400" cy="201168"/>
-          </a:xfrm>
-          <a:prstGeom prst="rect">
-            <a:avLst/>
-          </a:prstGeom>
-          <a:noFill/>
-        </p:spPr>
-        <p:txBody>
-          <a:bodyPr wrap="square" anchor="t" lIns="0" tIns="0" rIns="0" bIns="0">
-            <a:spAutoFit/>
-          </a:bodyPr>
-          <a:lstStyle/>
-          <a:p>
-            <a:pPr algn="l">
-              <a:lnSpc>
-                <a:spcPct val="100000"/>
-              </a:lnSpc>
-              <a:spcAft>
-                <a:spcPts val="0"/>
-              </a:spcAft>
-            </a:pPr>
-            <a:r>
-              <a:rPr sz="900" b="1">
-                <a:solidFill>
-                  <a:srgbClr val="94A3B8"/>
-                </a:solidFill>
-                <a:latin typeface="Arial"/>
-              </a:rPr>
-              <a:t>WHAT THE 50-CASE SAMPLE SHOWED</a:t>
-            </a:r>
-          </a:p>
-        </p:txBody>
-      </p:sp>
-      <p:sp>
-        <p:nvSpPr>
-          <p:cNvPr id="10" name="Rounded Rectangle 9"/>
+          <p:cNvPr id="9" name="Rounded Rectangle 8"/>
           <p:cNvSpPr/>
           <p:nvPr/>
         </p:nvSpPr>
         <p:spPr>
           <a:xfrm>
-            <a:off x="502920" y="3127248"/>
-            <a:ext cx="3630168" cy="987552"/>
-          </a:xfrm>
-          <a:prstGeom prst="roundRect">
-            <a:avLst>
-              <a:gd name="adj" fmla="val 4500"/>
-            </a:avLst>
-          </a:prstGeom>
-          <a:solidFill>
-            <a:srgbClr val="FDECEC"/>
-          </a:solidFill>
-          <a:ln>
-            <a:noFill/>
-          </a:ln>
-          <a:effectLst/>
-        </p:spPr>
-        <p:style>
-          <a:lnRef idx="1">
-            <a:schemeClr val="accent1"/>
-          </a:lnRef>
-          <a:fillRef idx="3">
-            <a:schemeClr val="accent1"/>
-          </a:fillRef>
-          <a:effectRef idx="2">
-            <a:schemeClr val="accent1"/>
-          </a:effectRef>
-          <a:fontRef idx="minor">
-            <a:schemeClr val="lt1"/>
-          </a:fontRef>
-        </p:style>
-        <p:txBody>
-          <a:bodyPr rtlCol="0" anchor="ctr" wrap="square" lIns="73152" tIns="54864" rIns="73152" bIns="54864"/>
-          <a:lstStyle/>
-          <a:p>
-            <a:pPr algn="ctr">
-              <a:lnSpc>
-                <a:spcPct val="100000"/>
-              </a:lnSpc>
-              <a:spcAft>
-                <a:spcPts val="200"/>
-              </a:spcAft>
-            </a:pPr>
-            <a:r>
-              <a:rPr sz="3000" b="1">
-                <a:solidFill>
-                  <a:srgbClr val="B91C1C"/>
-                </a:solidFill>
-                <a:latin typeface="Arial"/>
-              </a:rPr>
-              <a:t>8</a:t>
-            </a:r>
-          </a:p>
-          <a:p>
-            <a:pPr algn="ctr">
-              <a:lnSpc>
-                <a:spcPct val="95000"/>
-              </a:lnSpc>
-              <a:spcAft>
-                <a:spcPts val="0"/>
-              </a:spcAft>
-            </a:pPr>
-            <a:r>
-              <a:rPr sz="950" b="0">
-                <a:solidFill>
-                  <a:srgbClr val="64748B"/>
-                </a:solidFill>
-                <a:latin typeface="Arial"/>
-              </a:rPr>
-              <a:t>extreme on every signal</a:t>
-            </a:r>
-          </a:p>
-        </p:txBody>
-      </p:sp>
-      <p:sp>
-        <p:nvSpPr>
-          <p:cNvPr id="11" name="Rounded Rectangle 10"/>
-          <p:cNvSpPr/>
-          <p:nvPr/>
-        </p:nvSpPr>
-        <p:spPr>
-          <a:xfrm>
-            <a:off x="4242816" y="3127248"/>
-            <a:ext cx="3630168" cy="987552"/>
-          </a:xfrm>
-          <a:prstGeom prst="roundRect">
-            <a:avLst>
-              <a:gd name="adj" fmla="val 4500"/>
-            </a:avLst>
-          </a:prstGeom>
-          <a:solidFill>
-            <a:srgbClr val="FFF3EA"/>
-          </a:solidFill>
-          <a:ln>
-            <a:noFill/>
-          </a:ln>
-          <a:effectLst/>
-        </p:spPr>
-        <p:style>
-          <a:lnRef idx="1">
-            <a:schemeClr val="accent1"/>
-          </a:lnRef>
-          <a:fillRef idx="3">
-            <a:schemeClr val="accent1"/>
-          </a:fillRef>
-          <a:effectRef idx="2">
-            <a:schemeClr val="accent1"/>
-          </a:effectRef>
-          <a:fontRef idx="minor">
-            <a:schemeClr val="lt1"/>
-          </a:fontRef>
-        </p:style>
-        <p:txBody>
-          <a:bodyPr rtlCol="0" anchor="ctr" wrap="square" lIns="73152" tIns="54864" rIns="73152" bIns="54864"/>
-          <a:lstStyle/>
-          <a:p>
-            <a:pPr algn="ctr">
-              <a:lnSpc>
-                <a:spcPct val="100000"/>
-              </a:lnSpc>
-              <a:spcAft>
-                <a:spcPts val="200"/>
-              </a:spcAft>
-            </a:pPr>
-            <a:r>
-              <a:rPr sz="3000" b="1">
-                <a:solidFill>
-                  <a:srgbClr val="C2410C"/>
-                </a:solidFill>
-                <a:latin typeface="Arial"/>
-              </a:rPr>
-              <a:t>9</a:t>
-            </a:r>
-          </a:p>
-          <a:p>
-            <a:pPr algn="ctr">
-              <a:lnSpc>
-                <a:spcPct val="95000"/>
-              </a:lnSpc>
-              <a:spcAft>
-                <a:spcPts val="0"/>
-              </a:spcAft>
-            </a:pPr>
-            <a:r>
-              <a:rPr sz="950" b="0">
-                <a:solidFill>
-                  <a:srgbClr val="64748B"/>
-                </a:solidFill>
-                <a:latin typeface="Arial"/>
-              </a:rPr>
-              <a:t>genuinely ambiguous</a:t>
-            </a:r>
-          </a:p>
-        </p:txBody>
-      </p:sp>
-      <p:sp>
-        <p:nvSpPr>
-          <p:cNvPr id="12" name="Rounded Rectangle 11"/>
-          <p:cNvSpPr/>
-          <p:nvPr/>
-        </p:nvSpPr>
-        <p:spPr>
-          <a:xfrm>
-            <a:off x="7982712" y="3127248"/>
-            <a:ext cx="3703320" cy="987552"/>
-          </a:xfrm>
-          <a:prstGeom prst="roundRect">
-            <a:avLst>
-              <a:gd name="adj" fmla="val 4500"/>
-            </a:avLst>
-          </a:prstGeom>
-          <a:solidFill>
-            <a:srgbClr val="E6F5EF"/>
-          </a:solidFill>
-          <a:ln>
-            <a:noFill/>
-          </a:ln>
-          <a:effectLst/>
-        </p:spPr>
-        <p:style>
-          <a:lnRef idx="1">
-            <a:schemeClr val="accent1"/>
-          </a:lnRef>
-          <a:fillRef idx="3">
-            <a:schemeClr val="accent1"/>
-          </a:fillRef>
-          <a:effectRef idx="2">
-            <a:schemeClr val="accent1"/>
-          </a:effectRef>
-          <a:fontRef idx="minor">
-            <a:schemeClr val="lt1"/>
-          </a:fontRef>
-        </p:style>
-        <p:txBody>
-          <a:bodyPr rtlCol="0" anchor="ctr" wrap="square" lIns="73152" tIns="54864" rIns="73152" bIns="54864"/>
-          <a:lstStyle/>
-          <a:p>
-            <a:pPr algn="ctr">
-              <a:lnSpc>
-                <a:spcPct val="100000"/>
-              </a:lnSpc>
-              <a:spcAft>
-                <a:spcPts val="200"/>
-              </a:spcAft>
-            </a:pPr>
-            <a:r>
-              <a:rPr sz="3000" b="1">
-                <a:solidFill>
-                  <a:srgbClr val="047857"/>
-                </a:solidFill>
-                <a:latin typeface="Arial"/>
-              </a:rPr>
-              <a:t>33</a:t>
-            </a:r>
-          </a:p>
-          <a:p>
-            <a:pPr algn="ctr">
-              <a:lnSpc>
-                <a:spcPct val="95000"/>
-              </a:lnSpc>
-              <a:spcAft>
-                <a:spcPts val="0"/>
-              </a:spcAft>
-            </a:pPr>
-            <a:r>
-              <a:rPr sz="950" b="0">
-                <a:solidFill>
-                  <a:srgbClr val="64748B"/>
-                </a:solidFill>
-                <a:latin typeface="Arial"/>
-              </a:rPr>
-              <a:t>clean</a:t>
-            </a:r>
-          </a:p>
-        </p:txBody>
-      </p:sp>
-      <p:sp>
-        <p:nvSpPr>
-          <p:cNvPr id="13" name="Rounded Rectangle 12"/>
-          <p:cNvSpPr/>
-          <p:nvPr/>
-        </p:nvSpPr>
-        <p:spPr>
-          <a:xfrm>
-            <a:off x="502920" y="4242816"/>
-            <a:ext cx="11183112" cy="566928"/>
+            <a:off x="502920" y="2706624"/>
+            <a:ext cx="11183112" cy="603504"/>
           </a:xfrm>
           <a:prstGeom prst="roundRect">
             <a:avLst>
@@ -4527,7 +4248,7 @@
                 </a:solidFill>
                 <a:latin typeface="Arial"/>
               </a:rPr>
-              <a:t>So: rules take the obvious 41. Agents and humans spend their time on the 9 — plus the links no single row reveals: </a:t>
+              <a:t>The system in one line.  </a:t>
             </a:r>
             <a:r>
               <a:rPr sz="1100" b="0">
@@ -4536,20 +4257,20 @@
                 </a:solidFill>
                 <a:latin typeface="Arial"/>
               </a:rPr>
-              <a:t>3 cases trip no flag yet carry five elevated signals, and one claim number sits on a clean case and a critical one.</a:t>
-            </a:r>
-          </a:p>
-        </p:txBody>
-      </p:sp>
-      <p:sp>
-        <p:nvSpPr>
-          <p:cNvPr id="14" name="TextBox 13"/>
+              <a:t>It scores every referral with rules calibrated from the data, reasons over the cases that are genuinely unclear, and hands the investigator a ranked queue — each case with a summary, cited evidence, a risk level and a recommended action.</a:t>
+            </a:r>
+          </a:p>
+        </p:txBody>
+      </p:sp>
+      <p:sp>
+        <p:nvSpPr>
+          <p:cNvPr id="10" name="TextBox 9"/>
           <p:cNvSpPr txBox="1"/>
           <p:nvPr/>
         </p:nvSpPr>
         <p:spPr>
           <a:xfrm>
-            <a:off x="502920" y="5029200"/>
+            <a:off x="502920" y="3456432"/>
             <a:ext cx="5486400" cy="201168"/>
           </a:xfrm>
           <a:prstGeom prst="rect">
@@ -4578,29 +4299,29 @@
                 </a:solidFill>
                 <a:latin typeface="Arial"/>
               </a:rPr>
-              <a:t>BUILT IN THE PROTOTYPE</a:t>
-            </a:r>
-          </a:p>
-        </p:txBody>
-      </p:sp>
-      <p:sp>
-        <p:nvSpPr>
-          <p:cNvPr id="15" name="Rounded Rectangle 14"/>
+              <a:t>WHAT I BUILT</a:t>
+            </a:r>
+          </a:p>
+        </p:txBody>
+      </p:sp>
+      <p:sp>
+        <p:nvSpPr>
+          <p:cNvPr id="11" name="Rounded Rectangle 10"/>
           <p:cNvSpPr/>
           <p:nvPr/>
         </p:nvSpPr>
         <p:spPr>
           <a:xfrm>
-            <a:off x="502920" y="5285232"/>
-            <a:ext cx="1399032" cy="256032"/>
+            <a:off x="502920" y="3712463"/>
+            <a:ext cx="2395728" cy="786384"/>
           </a:xfrm>
           <a:prstGeom prst="roundRect">
             <a:avLst>
-              <a:gd name="adj" fmla="val 50000"/>
+              <a:gd name="adj" fmla="val 4500"/>
             </a:avLst>
           </a:prstGeom>
           <a:solidFill>
-            <a:srgbClr val="EEF3FE"/>
+            <a:srgbClr val="F6F8FB"/>
           </a:solidFill>
           <a:ln>
             <a:noFill/>
@@ -4622,47 +4343,66 @@
           </a:fontRef>
         </p:style>
         <p:txBody>
-          <a:bodyPr rtlCol="0" anchor="ctr" wrap="square" lIns="45720" tIns="0" rIns="45720" bIns="0"/>
-          <a:lstStyle/>
-          <a:p>
-            <a:pPr algn="ctr">
+          <a:bodyPr rtlCol="0" anchor="t" wrap="square" lIns="128016" tIns="100584" rIns="109728" bIns="73152"/>
+          <a:lstStyle/>
+          <a:p>
+            <a:pPr algn="l">
               <a:lnSpc>
                 <a:spcPct val="100000"/>
               </a:lnSpc>
               <a:spcAft>
+                <a:spcPts val="300"/>
+              </a:spcAft>
+            </a:pPr>
+            <a:r>
+              <a:rPr sz="1050" b="1">
+                <a:solidFill>
+                  <a:srgbClr val="0F172A"/>
+                </a:solidFill>
+                <a:latin typeface="Arial"/>
+              </a:rPr>
+              <a:t>Morning briefing</a:t>
+            </a:r>
+          </a:p>
+          <a:p>
+            <a:pPr algn="l">
+              <a:lnSpc>
+                <a:spcPct val="112000"/>
+              </a:lnSpc>
+              <a:spcAft>
                 <a:spcPts val="0"/>
               </a:spcAft>
             </a:pPr>
             <a:r>
-              <a:rPr sz="850" b="1">
-                <a:solidFill>
-                  <a:srgbClr val="1D4ED8"/>
-                </a:solidFill>
-                <a:latin typeface="Arial"/>
-              </a:rPr>
-              <a:t>Morning briefing</a:t>
-            </a:r>
-          </a:p>
-        </p:txBody>
-      </p:sp>
-      <p:sp>
-        <p:nvSpPr>
-          <p:cNvPr id="16" name="Rounded Rectangle 15"/>
+              <a:rPr sz="900" b="0">
+                <a:solidFill>
+                  <a:srgbClr val="64748B"/>
+                </a:solidFill>
+                <a:latin typeface="Arial"/>
+              </a:rPr>
+              <a:t>Risk counts, exposure, rule clusters, abnormal firing</a:t>
+            </a:r>
+          </a:p>
+        </p:txBody>
+      </p:sp>
+      <p:sp>
+        <p:nvSpPr>
+          <p:cNvPr id="12" name="Rounded Rectangle 11"/>
           <p:cNvSpPr/>
           <p:nvPr/>
         </p:nvSpPr>
         <p:spPr>
           <a:xfrm>
-            <a:off x="1993391" y="5285232"/>
-            <a:ext cx="1399032" cy="256032"/>
+            <a:off x="3054096" y="3712463"/>
+            <a:ext cx="2395728" cy="786384"/>
           </a:xfrm>
           <a:prstGeom prst="roundRect">
             <a:avLst>
-              <a:gd name="adj" fmla="val 50000"/>
+              <a:gd name="adj" fmla="val 4500"/>
             </a:avLst>
           </a:prstGeom>
           <a:solidFill>
-            <a:srgbClr val="EEF3FE"/>
+            <a:srgbClr val="F6F8FB"/>
           </a:solidFill>
           <a:ln>
             <a:noFill/>
@@ -4684,47 +4424,66 @@
           </a:fontRef>
         </p:style>
         <p:txBody>
-          <a:bodyPr rtlCol="0" anchor="ctr" wrap="square" lIns="45720" tIns="0" rIns="45720" bIns="0"/>
-          <a:lstStyle/>
-          <a:p>
-            <a:pPr algn="ctr">
+          <a:bodyPr rtlCol="0" anchor="t" wrap="square" lIns="128016" tIns="100584" rIns="109728" bIns="73152"/>
+          <a:lstStyle/>
+          <a:p>
+            <a:pPr algn="l">
               <a:lnSpc>
                 <a:spcPct val="100000"/>
               </a:lnSpc>
               <a:spcAft>
+                <a:spcPts val="300"/>
+              </a:spcAft>
+            </a:pPr>
+            <a:r>
+              <a:rPr sz="1050" b="1">
+                <a:solidFill>
+                  <a:srgbClr val="0F172A"/>
+                </a:solidFill>
+                <a:latin typeface="Arial"/>
+              </a:rPr>
+              <a:t>Per-case assessment</a:t>
+            </a:r>
+          </a:p>
+          <a:p>
+            <a:pPr algn="l">
+              <a:lnSpc>
+                <a:spcPct val="112000"/>
+              </a:lnSpc>
+              <a:spcAft>
                 <a:spcPts val="0"/>
               </a:spcAft>
             </a:pPr>
             <a:r>
-              <a:rPr sz="850" b="1">
-                <a:solidFill>
-                  <a:srgbClr val="1D4ED8"/>
-                </a:solidFill>
-                <a:latin typeface="Arial"/>
-              </a:rPr>
-              <a:t>Per-case assessment</a:t>
-            </a:r>
-          </a:p>
-        </p:txBody>
-      </p:sp>
-      <p:sp>
-        <p:nvSpPr>
-          <p:cNvPr id="17" name="Rounded Rectangle 16"/>
+              <a:rPr sz="900" b="0">
+                <a:solidFill>
+                  <a:srgbClr val="64748B"/>
+                </a:solidFill>
+                <a:latin typeface="Arial"/>
+              </a:rPr>
+              <a:t>Summary, cited indicators, risk level, recommended action</a:t>
+            </a:r>
+          </a:p>
+        </p:txBody>
+      </p:sp>
+      <p:sp>
+        <p:nvSpPr>
+          <p:cNvPr id="13" name="Rounded Rectangle 12"/>
           <p:cNvSpPr/>
           <p:nvPr/>
         </p:nvSpPr>
         <p:spPr>
           <a:xfrm>
-            <a:off x="3483863" y="5285232"/>
-            <a:ext cx="1399032" cy="256032"/>
+            <a:off x="5605272" y="3712463"/>
+            <a:ext cx="2395728" cy="786384"/>
           </a:xfrm>
           <a:prstGeom prst="roundRect">
             <a:avLst>
-              <a:gd name="adj" fmla="val 50000"/>
+              <a:gd name="adj" fmla="val 4500"/>
             </a:avLst>
           </a:prstGeom>
           <a:solidFill>
-            <a:srgbClr val="EEF3FE"/>
+            <a:srgbClr val="F6F8FB"/>
           </a:solidFill>
           <a:ln>
             <a:noFill/>
@@ -4746,47 +4505,66 @@
           </a:fontRef>
         </p:style>
         <p:txBody>
-          <a:bodyPr rtlCol="0" anchor="ctr" wrap="square" lIns="45720" tIns="0" rIns="45720" bIns="0"/>
-          <a:lstStyle/>
-          <a:p>
-            <a:pPr algn="ctr">
+          <a:bodyPr rtlCol="0" anchor="t" wrap="square" lIns="128016" tIns="100584" rIns="109728" bIns="73152"/>
+          <a:lstStyle/>
+          <a:p>
+            <a:pPr algn="l">
               <a:lnSpc>
                 <a:spcPct val="100000"/>
               </a:lnSpc>
               <a:spcAft>
+                <a:spcPts val="300"/>
+              </a:spcAft>
+            </a:pPr>
+            <a:r>
+              <a:rPr sz="1050" b="1">
+                <a:solidFill>
+                  <a:srgbClr val="0F172A"/>
+                </a:solidFill>
+                <a:latin typeface="Arial"/>
+              </a:rPr>
+              <a:t>Full agent trace</a:t>
+            </a:r>
+          </a:p>
+          <a:p>
+            <a:pPr algn="l">
+              <a:lnSpc>
+                <a:spcPct val="112000"/>
+              </a:lnSpc>
+              <a:spcAft>
                 <a:spcPts val="0"/>
               </a:spcAft>
             </a:pPr>
             <a:r>
-              <a:rPr sz="850" b="1">
-                <a:solidFill>
-                  <a:srgbClr val="1D4ED8"/>
-                </a:solidFill>
-                <a:latin typeface="Arial"/>
-              </a:rPr>
-              <a:t>Evidence + agent trace</a:t>
-            </a:r>
-          </a:p>
-        </p:txBody>
-      </p:sp>
-      <p:sp>
-        <p:nvSpPr>
-          <p:cNvPr id="18" name="Rounded Rectangle 17"/>
+              <a:rPr sz="900" b="0">
+                <a:solidFill>
+                  <a:srgbClr val="64748B"/>
+                </a:solidFill>
+                <a:latin typeface="Arial"/>
+              </a:rPr>
+              <a:t>Every step, tool call and cost, open for inspection</a:t>
+            </a:r>
+          </a:p>
+        </p:txBody>
+      </p:sp>
+      <p:sp>
+        <p:nvSpPr>
+          <p:cNvPr id="14" name="Rounded Rectangle 13"/>
           <p:cNvSpPr/>
           <p:nvPr/>
         </p:nvSpPr>
         <p:spPr>
           <a:xfrm>
-            <a:off x="4974336" y="5285232"/>
-            <a:ext cx="1399032" cy="256032"/>
+            <a:off x="502920" y="4608575"/>
+            <a:ext cx="2395728" cy="786384"/>
           </a:xfrm>
           <a:prstGeom prst="roundRect">
             <a:avLst>
-              <a:gd name="adj" fmla="val 50000"/>
+              <a:gd name="adj" fmla="val 4500"/>
             </a:avLst>
           </a:prstGeom>
           <a:solidFill>
-            <a:srgbClr val="EEF3FE"/>
+            <a:srgbClr val="F6F8FB"/>
           </a:solidFill>
           <a:ln>
             <a:noFill/>
@@ -4808,47 +4586,66 @@
           </a:fontRef>
         </p:style>
         <p:txBody>
-          <a:bodyPr rtlCol="0" anchor="ctr" wrap="square" lIns="45720" tIns="0" rIns="45720" bIns="0"/>
-          <a:lstStyle/>
-          <a:p>
-            <a:pPr algn="ctr">
+          <a:bodyPr rtlCol="0" anchor="t" wrap="square" lIns="128016" tIns="100584" rIns="109728" bIns="73152"/>
+          <a:lstStyle/>
+          <a:p>
+            <a:pPr algn="l">
               <a:lnSpc>
                 <a:spcPct val="100000"/>
               </a:lnSpc>
               <a:spcAft>
+                <a:spcPts val="300"/>
+              </a:spcAft>
+            </a:pPr>
+            <a:r>
+              <a:rPr sz="1050" b="1">
+                <a:solidFill>
+                  <a:srgbClr val="0F172A"/>
+                </a:solidFill>
+                <a:latin typeface="Arial"/>
+              </a:rPr>
+              <a:t>Ask, accept, reject</a:t>
+            </a:r>
+          </a:p>
+          <a:p>
+            <a:pPr algn="l">
+              <a:lnSpc>
+                <a:spcPct val="112000"/>
+              </a:lnSpc>
+              <a:spcAft>
                 <a:spcPts val="0"/>
               </a:spcAft>
             </a:pPr>
             <a:r>
-              <a:rPr sz="850" b="1">
-                <a:solidFill>
-                  <a:srgbClr val="1D4ED8"/>
-                </a:solidFill>
-                <a:latin typeface="Arial"/>
-              </a:rPr>
-              <a:t>Accept / reject / note</a:t>
-            </a:r>
-          </a:p>
-        </p:txBody>
-      </p:sp>
-      <p:sp>
-        <p:nvSpPr>
-          <p:cNvPr id="19" name="Rounded Rectangle 18"/>
+              <a:rPr sz="900" b="0">
+                <a:solidFill>
+                  <a:srgbClr val="64748B"/>
+                </a:solidFill>
+                <a:latin typeface="Arial"/>
+              </a:rPr>
+              <a:t>Chat over the case; a finding you reject is not re-asserted</a:t>
+            </a:r>
+          </a:p>
+        </p:txBody>
+      </p:sp>
+      <p:sp>
+        <p:nvSpPr>
+          <p:cNvPr id="15" name="Rounded Rectangle 14"/>
           <p:cNvSpPr/>
           <p:nvPr/>
         </p:nvSpPr>
         <p:spPr>
           <a:xfrm>
-            <a:off x="6464807" y="5285232"/>
-            <a:ext cx="1399032" cy="256032"/>
+            <a:off x="3054096" y="4608575"/>
+            <a:ext cx="2395728" cy="786384"/>
           </a:xfrm>
           <a:prstGeom prst="roundRect">
             <a:avLst>
-              <a:gd name="adj" fmla="val 50000"/>
+              <a:gd name="adj" fmla="val 4500"/>
             </a:avLst>
           </a:prstGeom>
           <a:solidFill>
-            <a:srgbClr val="EEF3FE"/>
+            <a:srgbClr val="F6F8FB"/>
           </a:solidFill>
           <a:ln>
             <a:noFill/>
@@ -4870,47 +4667,66 @@
           </a:fontRef>
         </p:style>
         <p:txBody>
-          <a:bodyPr rtlCol="0" anchor="ctr" wrap="square" lIns="45720" tIns="0" rIns="45720" bIns="0"/>
-          <a:lstStyle/>
-          <a:p>
-            <a:pPr algn="ctr">
+          <a:bodyPr rtlCol="0" anchor="t" wrap="square" lIns="128016" tIns="100584" rIns="109728" bIns="73152"/>
+          <a:lstStyle/>
+          <a:p>
+            <a:pPr algn="l">
               <a:lnSpc>
                 <a:spcPct val="100000"/>
               </a:lnSpc>
               <a:spcAft>
+                <a:spcPts val="300"/>
+              </a:spcAft>
+            </a:pPr>
+            <a:r>
+              <a:rPr sz="1050" b="1">
+                <a:solidFill>
+                  <a:srgbClr val="0F172A"/>
+                </a:solidFill>
+                <a:latin typeface="Arial"/>
+              </a:rPr>
+              <a:t>Notes that steer the AI</a:t>
+            </a:r>
+          </a:p>
+          <a:p>
+            <a:pPr algn="l">
+              <a:lnSpc>
+                <a:spcPct val="112000"/>
+              </a:lnSpc>
+              <a:spcAft>
                 <a:spcPts val="0"/>
               </a:spcAft>
             </a:pPr>
             <a:r>
-              <a:rPr sz="850" b="1">
-                <a:solidFill>
-                  <a:srgbClr val="1D4ED8"/>
-                </a:solidFill>
-                <a:latin typeface="Arial"/>
-              </a:rPr>
-              <a:t>Bulk clear, guarded</a:t>
-            </a:r>
-          </a:p>
-        </p:txBody>
-      </p:sp>
-      <p:sp>
-        <p:nvSpPr>
-          <p:cNvPr id="20" name="Rounded Rectangle 19"/>
+              <a:rPr sz="900" b="0">
+                <a:solidFill>
+                  <a:srgbClr val="64748B"/>
+                </a:solidFill>
+                <a:latin typeface="Arial"/>
+              </a:rPr>
+              <a:t>They change the next assessment, and purge everywhere on delete</a:t>
+            </a:r>
+          </a:p>
+        </p:txBody>
+      </p:sp>
+      <p:sp>
+        <p:nvSpPr>
+          <p:cNvPr id="16" name="Rounded Rectangle 15"/>
           <p:cNvSpPr/>
           <p:nvPr/>
         </p:nvSpPr>
         <p:spPr>
           <a:xfrm>
-            <a:off x="502920" y="5623560"/>
-            <a:ext cx="1399032" cy="256032"/>
+            <a:off x="5605272" y="4608575"/>
+            <a:ext cx="2395728" cy="786384"/>
           </a:xfrm>
           <a:prstGeom prst="roundRect">
             <a:avLst>
-              <a:gd name="adj" fmla="val 50000"/>
+              <a:gd name="adj" fmla="val 4500"/>
             </a:avLst>
           </a:prstGeom>
           <a:solidFill>
-            <a:srgbClr val="EEF3FE"/>
+            <a:srgbClr val="F6F8FB"/>
           </a:solidFill>
           <a:ln>
             <a:noFill/>
@@ -4932,47 +4748,66 @@
           </a:fontRef>
         </p:style>
         <p:txBody>
-          <a:bodyPr rtlCol="0" anchor="ctr" wrap="square" lIns="45720" tIns="0" rIns="45720" bIns="0"/>
-          <a:lstStyle/>
-          <a:p>
-            <a:pPr algn="ctr">
+          <a:bodyPr rtlCol="0" anchor="t" wrap="square" lIns="128016" tIns="100584" rIns="109728" bIns="73152"/>
+          <a:lstStyle/>
+          <a:p>
+            <a:pPr algn="l">
               <a:lnSpc>
                 <a:spcPct val="100000"/>
               </a:lnSpc>
               <a:spcAft>
+                <a:spcPts val="300"/>
+              </a:spcAft>
+            </a:pPr>
+            <a:r>
+              <a:rPr sz="1050" b="1">
+                <a:solidFill>
+                  <a:srgbClr val="0F172A"/>
+                </a:solidFill>
+                <a:latin typeface="Arial"/>
+              </a:rPr>
+              <a:t>Bulk clear, guarded</a:t>
+            </a:r>
+          </a:p>
+          <a:p>
+            <a:pPr algn="l">
+              <a:lnSpc>
+                <a:spcPct val="112000"/>
+              </a:lnSpc>
+              <a:spcAft>
                 <a:spcPts val="0"/>
               </a:spcAft>
             </a:pPr>
             <a:r>
-              <a:rPr sz="850" b="1">
-                <a:solidFill>
-                  <a:srgbClr val="1D4ED8"/>
-                </a:solidFill>
-                <a:latin typeface="Arial"/>
-              </a:rPr>
-              <a:t>Supervisor escalation</a:t>
-            </a:r>
-          </a:p>
-        </p:txBody>
-      </p:sp>
-      <p:sp>
-        <p:nvSpPr>
-          <p:cNvPr id="21" name="Rounded Rectangle 20"/>
+              <a:rPr sz="900" b="0">
+                <a:solidFill>
+                  <a:srgbClr val="64748B"/>
+                </a:solidFill>
+                <a:latin typeface="Arial"/>
+              </a:rPr>
+              <a:t>By filter or selection, previewing what it may not touch</a:t>
+            </a:r>
+          </a:p>
+        </p:txBody>
+      </p:sp>
+      <p:sp>
+        <p:nvSpPr>
+          <p:cNvPr id="17" name="Rounded Rectangle 16"/>
           <p:cNvSpPr/>
           <p:nvPr/>
         </p:nvSpPr>
         <p:spPr>
           <a:xfrm>
-            <a:off x="1993391" y="5623560"/>
-            <a:ext cx="1399032" cy="256032"/>
+            <a:off x="502920" y="5504688"/>
+            <a:ext cx="2395728" cy="786384"/>
           </a:xfrm>
           <a:prstGeom prst="roundRect">
             <a:avLst>
-              <a:gd name="adj" fmla="val 50000"/>
+              <a:gd name="adj" fmla="val 4500"/>
             </a:avLst>
           </a:prstGeom>
           <a:solidFill>
-            <a:srgbClr val="EEF3FE"/>
+            <a:srgbClr val="F6F8FB"/>
           </a:solidFill>
           <a:ln>
             <a:noFill/>
@@ -4994,47 +4829,66 @@
           </a:fontRef>
         </p:style>
         <p:txBody>
-          <a:bodyPr rtlCol="0" anchor="ctr" wrap="square" lIns="45720" tIns="0" rIns="45720" bIns="0"/>
-          <a:lstStyle/>
-          <a:p>
-            <a:pPr algn="ctr">
+          <a:bodyPr rtlCol="0" anchor="t" wrap="square" lIns="128016" tIns="100584" rIns="109728" bIns="73152"/>
+          <a:lstStyle/>
+          <a:p>
+            <a:pPr algn="l">
               <a:lnSpc>
                 <a:spcPct val="100000"/>
               </a:lnSpc>
               <a:spcAft>
+                <a:spcPts val="300"/>
+              </a:spcAft>
+            </a:pPr>
+            <a:r>
+              <a:rPr sz="1050" b="1">
+                <a:solidFill>
+                  <a:srgbClr val="0F172A"/>
+                </a:solidFill>
+                <a:latin typeface="Arial"/>
+              </a:rPr>
+              <a:t>Supervisor escalation</a:t>
+            </a:r>
+          </a:p>
+          <a:p>
+            <a:pPr algn="l">
+              <a:lnSpc>
+                <a:spcPct val="112000"/>
+              </a:lnSpc>
+              <a:spcAft>
                 <a:spcPts val="0"/>
               </a:spcAft>
             </a:pPr>
             <a:r>
-              <a:rPr sz="850" b="1">
-                <a:solidFill>
-                  <a:srgbClr val="1D4ED8"/>
-                </a:solidFill>
-                <a:latin typeface="Arial"/>
-              </a:rPr>
-              <a:t>Rules + backtest</a:t>
-            </a:r>
-          </a:p>
-        </p:txBody>
-      </p:sp>
-      <p:sp>
-        <p:nvSpPr>
-          <p:cNvPr id="22" name="Rounded Rectangle 21"/>
+              <a:rPr sz="900" b="0">
+                <a:solidFill>
+                  <a:srgbClr val="64748B"/>
+                </a:solidFill>
+                <a:latin typeface="Arial"/>
+              </a:rPr>
+              <a:t>AI-drafted handoff; the supervisor approves or returns it</a:t>
+            </a:r>
+          </a:p>
+        </p:txBody>
+      </p:sp>
+      <p:sp>
+        <p:nvSpPr>
+          <p:cNvPr id="18" name="Rounded Rectangle 17"/>
           <p:cNvSpPr/>
           <p:nvPr/>
         </p:nvSpPr>
         <p:spPr>
           <a:xfrm>
-            <a:off x="3483863" y="5623560"/>
-            <a:ext cx="1399032" cy="256032"/>
+            <a:off x="3054096" y="5504688"/>
+            <a:ext cx="2395728" cy="786384"/>
           </a:xfrm>
           <a:prstGeom prst="roundRect">
             <a:avLst>
-              <a:gd name="adj" fmla="val 50000"/>
+              <a:gd name="adj" fmla="val 4500"/>
             </a:avLst>
           </a:prstGeom>
           <a:solidFill>
-            <a:srgbClr val="EEF3FE"/>
+            <a:srgbClr val="F6F8FB"/>
           </a:solidFill>
           <a:ln>
             <a:noFill/>
@@ -5056,47 +4910,66 @@
           </a:fontRef>
         </p:style>
         <p:txBody>
-          <a:bodyPr rtlCol="0" anchor="ctr" wrap="square" lIns="45720" tIns="0" rIns="45720" bIns="0"/>
-          <a:lstStyle/>
-          <a:p>
-            <a:pPr algn="ctr">
+          <a:bodyPr rtlCol="0" anchor="t" wrap="square" lIns="128016" tIns="100584" rIns="109728" bIns="73152"/>
+          <a:lstStyle/>
+          <a:p>
+            <a:pPr algn="l">
               <a:lnSpc>
                 <a:spcPct val="100000"/>
               </a:lnSpc>
               <a:spcAft>
+                <a:spcPts val="300"/>
+              </a:spcAft>
+            </a:pPr>
+            <a:r>
+              <a:rPr sz="1050" b="1">
+                <a:solidFill>
+                  <a:srgbClr val="0F172A"/>
+                </a:solidFill>
+                <a:latin typeface="Arial"/>
+              </a:rPr>
+              <a:t>Rules and Blocklist</a:t>
+            </a:r>
+          </a:p>
+          <a:p>
+            <a:pPr algn="l">
+              <a:lnSpc>
+                <a:spcPct val="112000"/>
+              </a:lnSpc>
+              <a:spcAft>
                 <a:spcPts val="0"/>
               </a:spcAft>
             </a:pPr>
             <a:r>
-              <a:rPr sz="850" b="1">
-                <a:solidFill>
-                  <a:srgbClr val="1D4ED8"/>
-                </a:solidFill>
-                <a:latin typeface="Arial"/>
-              </a:rPr>
-              <a:t>Blocklist</a:t>
-            </a:r>
-          </a:p>
-        </p:txBody>
-      </p:sp>
-      <p:sp>
-        <p:nvSpPr>
-          <p:cNvPr id="23" name="Rounded Rectangle 22"/>
+              <a:rPr sz="900" b="0">
+                <a:solidFill>
+                  <a:srgbClr val="64748B"/>
+                </a:solidFill>
+                <a:latin typeface="Arial"/>
+              </a:rPr>
+              <a:t>Tune rules against a live backtest; hard rules that decline</a:t>
+            </a:r>
+          </a:p>
+        </p:txBody>
+      </p:sp>
+      <p:sp>
+        <p:nvSpPr>
+          <p:cNvPr id="19" name="Rounded Rectangle 18"/>
           <p:cNvSpPr/>
           <p:nvPr/>
         </p:nvSpPr>
         <p:spPr>
           <a:xfrm>
-            <a:off x="4974336" y="5623560"/>
-            <a:ext cx="1399032" cy="256032"/>
+            <a:off x="5605272" y="5504688"/>
+            <a:ext cx="2395728" cy="786384"/>
           </a:xfrm>
           <a:prstGeom prst="roundRect">
             <a:avLst>
-              <a:gd name="adj" fmla="val 50000"/>
+              <a:gd name="adj" fmla="val 4500"/>
             </a:avLst>
           </a:prstGeom>
           <a:solidFill>
-            <a:srgbClr val="EEF3FE"/>
+            <a:srgbClr val="F6F8FB"/>
           </a:solidFill>
           <a:ln>
             <a:noFill/>
@@ -5118,101 +4991,58 @@
           </a:fontRef>
         </p:style>
         <p:txBody>
-          <a:bodyPr rtlCol="0" anchor="ctr" wrap="square" lIns="45720" tIns="0" rIns="45720" bIns="0"/>
-          <a:lstStyle/>
-          <a:p>
-            <a:pPr algn="ctr">
+          <a:bodyPr rtlCol="0" anchor="t" wrap="square" lIns="128016" tIns="100584" rIns="109728" bIns="73152"/>
+          <a:lstStyle/>
+          <a:p>
+            <a:pPr algn="l">
               <a:lnSpc>
                 <a:spcPct val="100000"/>
               </a:lnSpc>
               <a:spcAft>
+                <a:spcPts val="300"/>
+              </a:spcAft>
+            </a:pPr>
+            <a:r>
+              <a:rPr sz="1050" b="1">
+                <a:solidFill>
+                  <a:srgbClr val="0F172A"/>
+                </a:solidFill>
+                <a:latin typeface="Arial"/>
+              </a:rPr>
+              <a:t>Outcome feedback + audit</a:t>
+            </a:r>
+          </a:p>
+          <a:p>
+            <a:pPr algn="l">
+              <a:lnSpc>
+                <a:spcPct val="112000"/>
+              </a:lnSpc>
+              <a:spcAft>
                 <a:spcPts val="0"/>
               </a:spcAft>
             </a:pPr>
             <a:r>
-              <a:rPr sz="850" b="1">
-                <a:solidFill>
-                  <a:srgbClr val="1D4ED8"/>
-                </a:solidFill>
-                <a:latin typeface="Arial"/>
-              </a:rPr>
-              <a:t>Outcome feedback</a:t>
-            </a:r>
-          </a:p>
-        </p:txBody>
-      </p:sp>
-      <p:sp>
-        <p:nvSpPr>
-          <p:cNvPr id="24" name="Rounded Rectangle 23"/>
-          <p:cNvSpPr/>
-          <p:nvPr/>
-        </p:nvSpPr>
-        <p:spPr>
-          <a:xfrm>
-            <a:off x="6464807" y="5623560"/>
-            <a:ext cx="1399032" cy="256032"/>
-          </a:xfrm>
-          <a:prstGeom prst="roundRect">
-            <a:avLst>
-              <a:gd name="adj" fmla="val 50000"/>
-            </a:avLst>
-          </a:prstGeom>
-          <a:solidFill>
-            <a:srgbClr val="EEF3FE"/>
-          </a:solidFill>
-          <a:ln>
-            <a:noFill/>
-          </a:ln>
-          <a:effectLst/>
-        </p:spPr>
-        <p:style>
-          <a:lnRef idx="1">
-            <a:schemeClr val="accent1"/>
-          </a:lnRef>
-          <a:fillRef idx="3">
-            <a:schemeClr val="accent1"/>
-          </a:fillRef>
-          <a:effectRef idx="2">
-            <a:schemeClr val="accent1"/>
-          </a:effectRef>
-          <a:fontRef idx="minor">
-            <a:schemeClr val="lt1"/>
-          </a:fontRef>
-        </p:style>
-        <p:txBody>
-          <a:bodyPr rtlCol="0" anchor="ctr" wrap="square" lIns="45720" tIns="0" rIns="45720" bIns="0"/>
-          <a:lstStyle/>
-          <a:p>
-            <a:pPr algn="ctr">
-              <a:lnSpc>
-                <a:spcPct val="100000"/>
-              </a:lnSpc>
-              <a:spcAft>
-                <a:spcPts val="0"/>
-              </a:spcAft>
-            </a:pPr>
-            <a:r>
-              <a:rPr sz="850" b="1">
-                <a:solidFill>
-                  <a:srgbClr val="1D4ED8"/>
-                </a:solidFill>
-                <a:latin typeface="Arial"/>
-              </a:rPr>
-              <a:t>Audit log</a:t>
-            </a:r>
-          </a:p>
-        </p:txBody>
-      </p:sp>
-      <p:sp>
-        <p:nvSpPr>
-          <p:cNvPr id="25" name="TextBox 24"/>
+              <a:rPr sz="900" b="0">
+                <a:solidFill>
+                  <a:srgbClr val="64748B"/>
+                </a:solidFill>
+                <a:latin typeface="Arial"/>
+              </a:rPr>
+              <a:t>Confirmed fraud flags lookalikes; every action is logged</a:t>
+            </a:r>
+          </a:p>
+        </p:txBody>
+      </p:sp>
+      <p:sp>
+        <p:nvSpPr>
+          <p:cNvPr id="20" name="TextBox 19"/>
           <p:cNvSpPr txBox="1"/>
           <p:nvPr/>
         </p:nvSpPr>
         <p:spPr>
           <a:xfrm>
-            <a:off x="8092440" y="5029200"/>
-            <a:ext cx="3593592" cy="201168"/>
+            <a:off x="8229600" y="3456432"/>
+            <a:ext cx="3456432" cy="201168"/>
           </a:xfrm>
           <a:prstGeom prst="rect">
             <a:avLst/>
@@ -5240,25 +5070,25 @@
                 </a:solidFill>
                 <a:latin typeface="Arial"/>
               </a:rPr>
-              <a:t>LEFT OUT ON PURPOSE</a:t>
-            </a:r>
-          </a:p>
-        </p:txBody>
-      </p:sp>
-      <p:sp>
-        <p:nvSpPr>
-          <p:cNvPr id="26" name="Rounded Rectangle 25"/>
+              <a:t>WHAT I LEFT OUT, AND WHY</a:t>
+            </a:r>
+          </a:p>
+        </p:txBody>
+      </p:sp>
+      <p:sp>
+        <p:nvSpPr>
+          <p:cNvPr id="21" name="Rounded Rectangle 20"/>
           <p:cNvSpPr/>
           <p:nvPr/>
         </p:nvSpPr>
         <p:spPr>
           <a:xfrm>
-            <a:off x="8092440" y="5285232"/>
-            <a:ext cx="3593592" cy="310896"/>
+            <a:off x="8229600" y="3712463"/>
+            <a:ext cx="3456432" cy="621792"/>
           </a:xfrm>
           <a:prstGeom prst="roundRect">
             <a:avLst>
-              <a:gd name="adj" fmla="val 12000"/>
+              <a:gd name="adj" fmla="val 4500"/>
             </a:avLst>
           </a:prstGeom>
           <a:solidFill>
@@ -5286,52 +5116,52 @@
           </a:fontRef>
         </p:style>
         <p:txBody>
-          <a:bodyPr rtlCol="0" anchor="ctr" wrap="square" lIns="109728" tIns="0" bIns="0"/>
+          <a:bodyPr rtlCol="0" anchor="ctr" wrap="square" lIns="128016" tIns="0" rIns="109728" bIns="0"/>
           <a:lstStyle/>
           <a:p>
             <a:pPr algn="l">
               <a:lnSpc>
-                <a:spcPct val="100000"/>
+                <a:spcPct val="114000"/>
               </a:lnSpc>
               <a:spcAft>
                 <a:spcPts val="0"/>
               </a:spcAft>
             </a:pPr>
             <a:r>
-              <a:rPr sz="900" b="1">
+              <a:rPr sz="950" b="1">
+                <a:solidFill>
+                  <a:srgbClr val="0F172A"/>
+                </a:solidFill>
+                <a:latin typeface="Arial"/>
+              </a:rPr>
+              <a:t>Auth and multi-tenancy — </a:t>
+            </a:r>
+            <a:r>
+              <a:rPr sz="950" b="0">
                 <a:solidFill>
                   <a:srgbClr val="64748B"/>
                 </a:solidFill>
                 <a:latin typeface="Arial"/>
               </a:rPr>
-              <a:t>Auth, multi-tenancy, deploy  </a:t>
-            </a:r>
-            <a:r>
-              <a:rPr sz="900" b="0">
-                <a:solidFill>
-                  <a:srgbClr val="94A3B8"/>
-                </a:solidFill>
-                <a:latin typeface="Arial"/>
-              </a:rPr>
-              <a:t>out of scope in the brief</a:t>
-            </a:r>
-          </a:p>
-        </p:txBody>
-      </p:sp>
-      <p:sp>
-        <p:nvSpPr>
-          <p:cNvPr id="27" name="Rounded Rectangle 26"/>
+              <a:t>out of scope in the brief — investigator and supervisor are personas you switch between</a:t>
+            </a:r>
+          </a:p>
+        </p:txBody>
+      </p:sp>
+      <p:sp>
+        <p:nvSpPr>
+          <p:cNvPr id="22" name="Rounded Rectangle 21"/>
           <p:cNvSpPr/>
           <p:nvPr/>
         </p:nvSpPr>
         <p:spPr>
           <a:xfrm>
-            <a:off x="8092440" y="5641848"/>
-            <a:ext cx="3593592" cy="310896"/>
+            <a:off x="8229600" y="4370831"/>
+            <a:ext cx="3456432" cy="621792"/>
           </a:xfrm>
           <a:prstGeom prst="roundRect">
             <a:avLst>
-              <a:gd name="adj" fmla="val 12000"/>
+              <a:gd name="adj" fmla="val 4500"/>
             </a:avLst>
           </a:prstGeom>
           <a:solidFill>
@@ -5359,52 +5189,52 @@
           </a:fontRef>
         </p:style>
         <p:txBody>
-          <a:bodyPr rtlCol="0" anchor="ctr" wrap="square" lIns="109728" tIns="0" bIns="0"/>
+          <a:bodyPr rtlCol="0" anchor="ctr" wrap="square" lIns="128016" tIns="0" rIns="109728" bIns="0"/>
           <a:lstStyle/>
           <a:p>
             <a:pPr algn="l">
               <a:lnSpc>
-                <a:spcPct val="100000"/>
+                <a:spcPct val="114000"/>
               </a:lnSpc>
               <a:spcAft>
                 <a:spcPts val="0"/>
               </a:spcAft>
             </a:pPr>
             <a:r>
-              <a:rPr sz="900" b="1">
+              <a:rPr sz="950" b="1">
+                <a:solidFill>
+                  <a:srgbClr val="0F172A"/>
+                </a:solidFill>
+                <a:latin typeface="Arial"/>
+              </a:rPr>
+              <a:t>A trained ML model — </a:t>
+            </a:r>
+            <a:r>
+              <a:rPr sz="950" b="0">
                 <a:solidFill>
                   <a:srgbClr val="64748B"/>
                 </a:solidFill>
                 <a:latin typeface="Arial"/>
               </a:rPr>
-              <a:t>A trained ML model  </a:t>
-            </a:r>
-            <a:r>
-              <a:rPr sz="900" b="0">
-                <a:solidFill>
-                  <a:srgbClr val="94A3B8"/>
-                </a:solidFill>
-                <a:latin typeface="Arial"/>
-              </a:rPr>
-              <a:t>no labels — accuracy would be invented</a:t>
-            </a:r>
-          </a:p>
-        </p:txBody>
-      </p:sp>
-      <p:sp>
-        <p:nvSpPr>
-          <p:cNvPr id="28" name="Rounded Rectangle 27"/>
+              <a:t>the data carries no fraud labels, so any accuracy figure would be fiction</a:t>
+            </a:r>
+          </a:p>
+        </p:txBody>
+      </p:sp>
+      <p:sp>
+        <p:nvSpPr>
+          <p:cNvPr id="23" name="Rounded Rectangle 22"/>
           <p:cNvSpPr/>
           <p:nvPr/>
         </p:nvSpPr>
         <p:spPr>
           <a:xfrm>
-            <a:off x="8092440" y="5998464"/>
-            <a:ext cx="3593592" cy="310896"/>
+            <a:off x="8229600" y="5029200"/>
+            <a:ext cx="3456432" cy="621792"/>
           </a:xfrm>
           <a:prstGeom prst="roundRect">
             <a:avLst>
-              <a:gd name="adj" fmla="val 12000"/>
+              <a:gd name="adj" fmla="val 4500"/>
             </a:avLst>
           </a:prstGeom>
           <a:solidFill>
@@ -5432,34 +5262,107 @@
           </a:fontRef>
         </p:style>
         <p:txBody>
-          <a:bodyPr rtlCol="0" anchor="ctr" wrap="square" lIns="109728" tIns="0" bIns="0"/>
+          <a:bodyPr rtlCol="0" anchor="ctr" wrap="square" lIns="128016" tIns="0" rIns="109728" bIns="0"/>
           <a:lstStyle/>
           <a:p>
             <a:pPr algn="l">
               <a:lnSpc>
-                <a:spcPct val="100000"/>
+                <a:spcPct val="114000"/>
               </a:lnSpc>
               <a:spcAft>
                 <a:spcPts val="0"/>
               </a:spcAft>
             </a:pPr>
             <a:r>
-              <a:rPr sz="900" b="1">
+              <a:rPr sz="950" b="1">
+                <a:solidFill>
+                  <a:srgbClr val="0F172A"/>
+                </a:solidFill>
+                <a:latin typeface="Arial"/>
+              </a:rPr>
+              <a:t>Provider / member graph — </a:t>
+            </a:r>
+            <a:r>
+              <a:rPr sz="950" b="0">
                 <a:solidFill>
                   <a:srgbClr val="64748B"/>
                 </a:solidFill>
                 <a:latin typeface="Arial"/>
               </a:rPr>
-              <a:t>Provider / member graph  </a:t>
-            </a:r>
-            <a:r>
-              <a:rPr sz="900" b="0">
-                <a:solidFill>
-                  <a:srgbClr val="94A3B8"/>
-                </a:solidFill>
-                <a:latin typeface="Arial"/>
-              </a:rPr>
-              <a:t>no IDs in the CSV; code is ready</a:t>
+              <a:t>the CSV has no such IDs; the linkage code is written and runs on claim number today</a:t>
+            </a:r>
+          </a:p>
+        </p:txBody>
+      </p:sp>
+      <p:sp>
+        <p:nvSpPr>
+          <p:cNvPr id="24" name="Rounded Rectangle 23"/>
+          <p:cNvSpPr/>
+          <p:nvPr/>
+        </p:nvSpPr>
+        <p:spPr>
+          <a:xfrm>
+            <a:off x="8229600" y="5687568"/>
+            <a:ext cx="3456432" cy="621792"/>
+          </a:xfrm>
+          <a:prstGeom prst="roundRect">
+            <a:avLst>
+              <a:gd name="adj" fmla="val 4500"/>
+            </a:avLst>
+          </a:prstGeom>
+          <a:solidFill>
+            <a:srgbClr val="FFFFFF"/>
+          </a:solidFill>
+          <a:ln w="12700">
+            <a:solidFill>
+              <a:srgbClr val="E2E8F0"/>
+            </a:solidFill>
+          </a:ln>
+          <a:effectLst/>
+        </p:spPr>
+        <p:style>
+          <a:lnRef idx="1">
+            <a:schemeClr val="accent1"/>
+          </a:lnRef>
+          <a:fillRef idx="3">
+            <a:schemeClr val="accent1"/>
+          </a:fillRef>
+          <a:effectRef idx="2">
+            <a:schemeClr val="accent1"/>
+          </a:effectRef>
+          <a:fontRef idx="minor">
+            <a:schemeClr val="lt1"/>
+          </a:fontRef>
+        </p:style>
+        <p:txBody>
+          <a:bodyPr rtlCol="0" anchor="ctr" wrap="square" lIns="128016" tIns="0" rIns="109728" bIns="0"/>
+          <a:lstStyle/>
+          <a:p>
+            <a:pPr algn="l">
+              <a:lnSpc>
+                <a:spcPct val="114000"/>
+              </a:lnSpc>
+              <a:spcAft>
+                <a:spcPts val="0"/>
+              </a:spcAft>
+            </a:pPr>
+            <a:r>
+              <a:rPr sz="950" b="1">
+                <a:solidFill>
+                  <a:srgbClr val="0F172A"/>
+                </a:solidFill>
+                <a:latin typeface="Arial"/>
+              </a:rPr>
+              <a:t>External enrichment — </a:t>
+            </a:r>
+            <a:r>
+              <a:rPr sz="950" b="0">
+                <a:solidFill>
+                  <a:srgbClr val="64748B"/>
+                </a:solidFill>
+                <a:latin typeface="Arial"/>
+              </a:rPr>
+              <a:t>public registries and search would be interesting, but are not the core AI experience</a:t>
             </a:r>
           </a:p>
         </p:txBody>
@@ -6979,7 +6882,7 @@
                 </a:solidFill>
                 <a:latin typeface="Arial"/>
               </a:rPr>
-              <a:t>Notes are untrusted input; bulk clear and broad blocklist entries are gated.</a:t>
+              <a:t>Bulk clear and over-broad blocklist entries are gated and previewed.</a:t>
             </a:r>
           </a:p>
         </p:txBody>
@@ -8460,7 +8363,7 @@
                 </a:solidFill>
                 <a:latin typeface="Arial"/>
               </a:rPr>
-              <a:t>Notes are untrusted text: a hidden instruction is not obeyed (tested)</a:t>
+              <a:t>Expert input is trusted as evidence — inside the same guardrails as every signal</a:t>
             </a:r>
           </a:p>
           <a:p>

</xml_diff>